<commit_message>
FINAL COMMIT (i guess)
</commit_message>
<xml_diff>
--- a/docs/presentation.pptx
+++ b/docs/presentation.pptx
@@ -4,9 +4,6 @@
   <p:sldMasterIdLst>
     <p:sldMasterId id="2147483648" r:id="rId1"/>
   </p:sldMasterIdLst>
-  <p:notesMasterIdLst>
-    <p:notesMasterId r:id="rId17"/>
-  </p:notesMasterIdLst>
   <p:sldIdLst>
     <p:sldId id="256" r:id="rId2"/>
     <p:sldId id="257" r:id="rId3"/>
@@ -24,6 +21,9 @@
     <p:sldId id="269" r:id="rId15"/>
     <p:sldId id="270" r:id="rId16"/>
   </p:sldIdLst>
+  <p:notesMasterIdLst>
+    <p:notesMasterId r:id="rId17"/>
+  </p:notesMasterIdLst>
   <p:sldSz cx="12192000" cy="6858000"/>
   <p:notesSz cx="6858000" cy="12192000"/>
   <p:defaultTextStyle>
@@ -118,11 +118,6 @@
       </a:defRPr>
     </a:lvl9pPr>
   </p:defaultTextStyle>
-  <p:extLst>
-    <p:ext uri="{EFAFB233-063F-42B5-8137-9DF3F51BA10A}">
-      <p15:sldGuideLst xmlns:p15="http://schemas.microsoft.com/office/powerpoint/2012/main"/>
-    </p:ext>
-  </p:extLst>
 </p:presentation>
 </file>
 
@@ -148,10 +143,234 @@
           <a:chExt cx="0" cy="0"/>
         </a:xfrm>
       </p:grpSpPr>
+      <p:sp>
+        <p:nvSpPr>
+          <p:cNvPr id="2" name="Header Placeholder 1"/>
+          <p:cNvSpPr>
+            <a:spLocks noGrp="1"/>
+          </p:cNvSpPr>
+          <p:nvPr>
+            <p:ph type="hdr" sz="quarter"/>
+          </p:nvPr>
+        </p:nvSpPr>
+        <p:spPr>
+          <a:xfrm>
+            <a:off x="0" y="0"/>
+            <a:ext cx="2971800" cy="458788"/>
+          </a:xfrm>
+          <a:prstGeom prst="rect">
+            <a:avLst/>
+          </a:prstGeom>
+        </p:spPr>
+        <p:txBody>
+          <a:bodyPr vert="horz" lIns="91440" tIns="45720" rIns="91440" bIns="45720" rtlCol="0"/>
+          <a:lstStyle>
+            <a:lvl1pPr algn="l">
+              <a:defRPr sz="1200"/>
+            </a:lvl1pPr>
+          </a:lstStyle>
+          <a:p>
+            <a:endParaRPr lang="en-US"/>
+          </a:p>
+        </p:txBody>
+      </p:sp>
+      <p:sp>
+        <p:nvSpPr>
+          <p:cNvPr id="3" name="Date Placeholder 2"/>
+          <p:cNvSpPr>
+            <a:spLocks noGrp="1"/>
+          </p:cNvSpPr>
+          <p:nvPr>
+            <p:ph type="dt" idx="1"/>
+          </p:nvPr>
+        </p:nvSpPr>
+        <p:spPr>
+          <a:xfrm>
+            <a:off x="3884613" y="0"/>
+            <a:ext cx="2971800" cy="458788"/>
+          </a:xfrm>
+          <a:prstGeom prst="rect">
+            <a:avLst/>
+          </a:prstGeom>
+        </p:spPr>
+        <p:txBody>
+          <a:bodyPr vert="horz" lIns="91440" tIns="45720" rIns="91440" bIns="45720" rtlCol="0"/>
+          <a:lstStyle>
+            <a:lvl1pPr algn="r">
+              <a:defRPr sz="1200"/>
+            </a:lvl1pPr>
+          </a:lstStyle>
+          <a:p>
+            <a:fld id="{5282F153-3F37-0F45-9E97-73ACFA13230C}" type="datetimeFigureOut">
+              <a:rPr lang="en-US"/>
+              <a:t>7/23/19</a:t>
+            </a:fld>
+            <a:endParaRPr lang="en-US"/>
+          </a:p>
+        </p:txBody>
+      </p:sp>
+      <p:sp>
+        <p:nvSpPr>
+          <p:cNvPr id="4" name="Slide Image Placeholder 3"/>
+          <p:cNvSpPr>
+            <a:spLocks noGrp="1" noRot="1" noChangeAspect="1"/>
+          </p:cNvSpPr>
+          <p:nvPr>
+            <p:ph type="sldImg" idx="2"/>
+          </p:nvPr>
+        </p:nvSpPr>
+        <p:spPr>
+          <a:xfrm>
+            <a:off x="685800" y="1143000"/>
+            <a:ext cx="5486400" cy="3086100"/>
+          </a:xfrm>
+          <a:prstGeom prst="rect">
+            <a:avLst/>
+          </a:prstGeom>
+          <a:noFill/>
+          <a:ln w="12700">
+            <a:solidFill>
+              <a:prstClr val="black"/>
+            </a:solidFill>
+          </a:ln>
+        </p:spPr>
+        <p:txBody>
+          <a:bodyPr vert="horz" lIns="91440" tIns="45720" rIns="91440" bIns="45720" rtlCol="0" anchor="ctr"/>
+          <a:lstStyle/>
+          <a:p>
+            <a:endParaRPr lang="en-US"/>
+          </a:p>
+        </p:txBody>
+      </p:sp>
+      <p:sp>
+        <p:nvSpPr>
+          <p:cNvPr id="5" name="Notes Placeholder 4"/>
+          <p:cNvSpPr>
+            <a:spLocks noGrp="1"/>
+          </p:cNvSpPr>
+          <p:nvPr>
+            <p:ph type="body" sz="quarter" idx="3"/>
+          </p:nvPr>
+        </p:nvSpPr>
+        <p:spPr>
+          <a:xfrm>
+            <a:off x="685800" y="4400550"/>
+            <a:ext cx="5486400" cy="3600450"/>
+          </a:xfrm>
+          <a:prstGeom prst="rect">
+            <a:avLst/>
+          </a:prstGeom>
+        </p:spPr>
+        <p:txBody>
+          <a:bodyPr vert="horz" lIns="91440" tIns="45720" rIns="91440" bIns="45720" rtlCol="0"/>
+          <a:lstStyle/>
+          <a:p>
+            <a:pPr lvl="0"/>
+            <a:r>
+              <a:rPr lang="en-US"/>
+              <a:t>Click to edit Master text styles</a:t>
+            </a:r>
+          </a:p>
+          <a:p>
+            <a:pPr lvl="1"/>
+            <a:r>
+              <a:rPr lang="en-US"/>
+              <a:t>Second level</a:t>
+            </a:r>
+          </a:p>
+          <a:p>
+            <a:pPr lvl="2"/>
+            <a:r>
+              <a:rPr lang="en-US"/>
+              <a:t>Third level</a:t>
+            </a:r>
+          </a:p>
+          <a:p>
+            <a:pPr lvl="3"/>
+            <a:r>
+              <a:rPr lang="en-US"/>
+              <a:t>Fourth level</a:t>
+            </a:r>
+          </a:p>
+          <a:p>
+            <a:pPr lvl="4"/>
+            <a:r>
+              <a:rPr lang="en-US"/>
+              <a:t>Fifth level</a:t>
+            </a:r>
+          </a:p>
+        </p:txBody>
+      </p:sp>
+      <p:sp>
+        <p:nvSpPr>
+          <p:cNvPr id="6" name="Footer Placeholder 5"/>
+          <p:cNvSpPr>
+            <a:spLocks noGrp="1"/>
+          </p:cNvSpPr>
+          <p:nvPr>
+            <p:ph type="ftr" sz="quarter" idx="4"/>
+          </p:nvPr>
+        </p:nvSpPr>
+        <p:spPr>
+          <a:xfrm>
+            <a:off x="0" y="8685213"/>
+            <a:ext cx="2971800" cy="458787"/>
+          </a:xfrm>
+          <a:prstGeom prst="rect">
+            <a:avLst/>
+          </a:prstGeom>
+        </p:spPr>
+        <p:txBody>
+          <a:bodyPr vert="horz" lIns="91440" tIns="45720" rIns="91440" bIns="45720" rtlCol="0" anchor="b"/>
+          <a:lstStyle>
+            <a:lvl1pPr algn="l">
+              <a:defRPr sz="1200"/>
+            </a:lvl1pPr>
+          </a:lstStyle>
+          <a:p>
+            <a:endParaRPr lang="en-US"/>
+          </a:p>
+        </p:txBody>
+      </p:sp>
+      <p:sp>
+        <p:nvSpPr>
+          <p:cNvPr id="7" name="Slide Number Placeholder 6"/>
+          <p:cNvSpPr>
+            <a:spLocks noGrp="1"/>
+          </p:cNvSpPr>
+          <p:nvPr>
+            <p:ph type="sldNum" sz="quarter" idx="5"/>
+          </p:nvPr>
+        </p:nvSpPr>
+        <p:spPr>
+          <a:xfrm>
+            <a:off x="3884613" y="8685213"/>
+            <a:ext cx="2971800" cy="458787"/>
+          </a:xfrm>
+          <a:prstGeom prst="rect">
+            <a:avLst/>
+          </a:prstGeom>
+        </p:spPr>
+        <p:txBody>
+          <a:bodyPr vert="horz" lIns="91440" tIns="45720" rIns="91440" bIns="45720" rtlCol="0" anchor="b"/>
+          <a:lstStyle>
+            <a:lvl1pPr algn="r">
+              <a:defRPr sz="1200"/>
+            </a:lvl1pPr>
+          </a:lstStyle>
+          <a:p>
+            <a:fld id="{CE5E9CC1-C706-0F49-92D6-E571CC5EEA8F}" type="slidenum">
+              <a:rPr lang="en-US"/>
+              <a:t>‹#›</a:t>
+            </a:fld>
+            <a:endParaRPr lang="en-US"/>
+          </a:p>
+        </p:txBody>
+      </p:sp>
     </p:spTree>
     <p:extLst>
       <p:ext uri="{BB962C8B-B14F-4D97-AF65-F5344CB8AC3E}">
-        <p14:creationId xmlns:p14="http://schemas.microsoft.com/office/powerpoint/2010/main" val="1283289860"/>
+        <p14:creationId xmlns:p14="http://schemas.microsoft.com/office/powerpoint/2010/main" val="1024086991"/>
       </p:ext>
     </p:extLst>
   </p:cSld>
@@ -295,6 +514,10 @@
           <a:bodyPr/>
           <a:lstStyle/>
           <a:p>
+            <a:r>
+              <a:rPr lang="en-US" dirty="0"/>
+              <a:t/>
+            </a:r>
             <a:endParaRPr lang="en-US" dirty="0"/>
           </a:p>
         </p:txBody>
@@ -379,6 +602,10 @@
           <a:bodyPr/>
           <a:lstStyle/>
           <a:p>
+            <a:r>
+              <a:rPr lang="en-US" dirty="0"/>
+              <a:t/>
+            </a:r>
             <a:endParaRPr lang="en-US" dirty="0"/>
           </a:p>
         </p:txBody>
@@ -463,6 +690,10 @@
           <a:bodyPr/>
           <a:lstStyle/>
           <a:p>
+            <a:r>
+              <a:rPr lang="en-US" dirty="0"/>
+              <a:t/>
+            </a:r>
             <a:endParaRPr lang="en-US" dirty="0"/>
           </a:p>
         </p:txBody>
@@ -547,6 +778,10 @@
           <a:bodyPr/>
           <a:lstStyle/>
           <a:p>
+            <a:r>
+              <a:rPr lang="en-US" dirty="0"/>
+              <a:t/>
+            </a:r>
             <a:endParaRPr lang="en-US" dirty="0"/>
           </a:p>
         </p:txBody>
@@ -631,6 +866,10 @@
           <a:bodyPr/>
           <a:lstStyle/>
           <a:p>
+            <a:r>
+              <a:rPr lang="en-US" dirty="0"/>
+              <a:t/>
+            </a:r>
             <a:endParaRPr lang="en-US" dirty="0"/>
           </a:p>
         </p:txBody>
@@ -715,6 +954,10 @@
           <a:bodyPr/>
           <a:lstStyle/>
           <a:p>
+            <a:r>
+              <a:rPr lang="en-US" dirty="0"/>
+              <a:t/>
+            </a:r>
             <a:endParaRPr lang="en-US" dirty="0"/>
           </a:p>
         </p:txBody>
@@ -799,6 +1042,10 @@
           <a:bodyPr/>
           <a:lstStyle/>
           <a:p>
+            <a:r>
+              <a:rPr lang="en-US" dirty="0"/>
+              <a:t/>
+            </a:r>
             <a:endParaRPr lang="en-US" dirty="0"/>
           </a:p>
         </p:txBody>
@@ -883,6 +1130,10 @@
           <a:bodyPr/>
           <a:lstStyle/>
           <a:p>
+            <a:r>
+              <a:rPr lang="en-US" dirty="0"/>
+              <a:t/>
+            </a:r>
             <a:endParaRPr lang="en-US" dirty="0"/>
           </a:p>
         </p:txBody>
@@ -967,6 +1218,10 @@
           <a:bodyPr/>
           <a:lstStyle/>
           <a:p>
+            <a:r>
+              <a:rPr lang="en-US" dirty="0"/>
+              <a:t/>
+            </a:r>
             <a:endParaRPr lang="en-US" dirty="0"/>
           </a:p>
         </p:txBody>
@@ -1051,6 +1306,10 @@
           <a:bodyPr/>
           <a:lstStyle/>
           <a:p>
+            <a:r>
+              <a:rPr lang="en-US" dirty="0"/>
+              <a:t/>
+            </a:r>
             <a:endParaRPr lang="en-US" dirty="0"/>
           </a:p>
         </p:txBody>
@@ -1135,6 +1394,10 @@
           <a:bodyPr/>
           <a:lstStyle/>
           <a:p>
+            <a:r>
+              <a:rPr lang="en-US" dirty="0"/>
+              <a:t/>
+            </a:r>
             <a:endParaRPr lang="en-US" dirty="0"/>
           </a:p>
         </p:txBody>
@@ -1219,6 +1482,10 @@
           <a:bodyPr/>
           <a:lstStyle/>
           <a:p>
+            <a:r>
+              <a:rPr lang="en-US" dirty="0"/>
+              <a:t/>
+            </a:r>
             <a:endParaRPr lang="en-US" dirty="0"/>
           </a:p>
         </p:txBody>
@@ -1303,6 +1570,10 @@
           <a:bodyPr/>
           <a:lstStyle/>
           <a:p>
+            <a:r>
+              <a:rPr lang="en-US" dirty="0"/>
+              <a:t/>
+            </a:r>
             <a:endParaRPr lang="en-US" dirty="0"/>
           </a:p>
         </p:txBody>
@@ -1387,6 +1658,10 @@
           <a:bodyPr/>
           <a:lstStyle/>
           <a:p>
+            <a:r>
+              <a:rPr lang="en-US" dirty="0"/>
+              <a:t/>
+            </a:r>
             <a:endParaRPr lang="en-US" dirty="0"/>
           </a:p>
         </p:txBody>
@@ -1471,6 +1746,10 @@
           <a:bodyPr/>
           <a:lstStyle/>
           <a:p>
+            <a:r>
+              <a:rPr lang="en-US" dirty="0"/>
+              <a:t/>
+            </a:r>
             <a:endParaRPr lang="en-US" dirty="0"/>
           </a:p>
         </p:txBody>
@@ -1544,11 +1823,6 @@
 <file path=ppt/slideMasters/slideMaster1.xml><?xml version="1.0" encoding="utf-8"?>
 <p:sldMaster xmlns:a="http://schemas.openxmlformats.org/drawingml/2006/main" xmlns:r="http://schemas.openxmlformats.org/officeDocument/2006/relationships" xmlns:p="http://schemas.openxmlformats.org/presentationml/2006/main">
   <p:cSld>
-    <p:bg>
-      <p:bgRef idx="1001">
-        <a:schemeClr val="bg1"/>
-      </p:bgRef>
-    </p:bg>
     <p:spTree>
       <p:nvGrpSpPr>
         <p:cNvPr id="1" name=""/>
@@ -1831,7 +2105,6 @@
         <a:solidFill>
           <a:srgbClr val="0B0F19"/>
         </a:solidFill>
-        <a:effectLst/>
       </p:bgPr>
     </p:bg>
     <p:spTree>
@@ -1896,7 +2169,7 @@
           <a:bodyPr wrap="square" rtlCol="0" anchor="ctr"/>
           <a:lstStyle/>
           <a:p>
-            <a:pPr marL="0" indent="0" algn="ctr">
+            <a:pPr algn="ctr" indent="0" marL="0">
               <a:buNone/>
             </a:pPr>
             <a:r>
@@ -1935,7 +2208,7 @@
           <a:bodyPr wrap="square" rtlCol="0" anchor="ctr"/>
           <a:lstStyle/>
           <a:p>
-            <a:pPr marL="0" indent="0" algn="ctr">
+            <a:pPr algn="ctr" indent="0" marL="0">
               <a:buNone/>
             </a:pPr>
             <a:r>
@@ -1974,7 +2247,7 @@
           <a:bodyPr wrap="square" rtlCol="0" anchor="ctr"/>
           <a:lstStyle/>
           <a:p>
-            <a:pPr marL="0" indent="0" algn="ctr">
+            <a:pPr algn="ctr" indent="0" marL="0">
               <a:buNone/>
             </a:pPr>
             <a:r>
@@ -1991,7 +2264,7 @@
             <a:endParaRPr lang="en-US" sz="1600" dirty="0"/>
           </a:p>
           <a:p>
-            <a:pPr marL="0" indent="0" algn="ctr">
+            <a:pPr algn="ctr" indent="0" marL="0">
               <a:buNone/>
             </a:pPr>
             <a:r>
@@ -2082,7 +2355,7 @@
           <a:bodyPr wrap="square" rtlCol="0" anchor="ctr"/>
           <a:lstStyle/>
           <a:p>
-            <a:pPr marL="0" indent="0">
+            <a:pPr indent="0" marL="0">
               <a:buNone/>
             </a:pPr>
             <a:r>
@@ -2094,9 +2367,12 @@
                 <a:ea typeface="Segoe UI" pitchFamily="34" charset="-122"/>
                 <a:cs typeface="Segoe UI" pitchFamily="34" charset="-120"/>
               </a:rPr>
-              <a:t>СПЕЦИАЛЬНОСТЬ
+              <a:t>СПЕЦИАЛЬНОСТЬ И МОДУЛЬ
 </a:t>
             </a:r>
+            <a:pPr indent="0" marL="0">
+              <a:buNone/>
+            </a:pPr>
             <a:r>
               <a:rPr lang="en-US" sz="1100" b="1" dirty="0">
                 <a:solidFill>
@@ -2106,18 +2382,22 @@
                 <a:ea typeface="Segoe UI" pitchFamily="34" charset="-122"/>
                 <a:cs typeface="Segoe UI" pitchFamily="34" charset="-120"/>
               </a:rPr>
-              <a:t>09.02.07 Информационные системы и </a:t>
-            </a:r>
-            <a:r>
-              <a:rPr lang="en-US" sz="1100" b="1" dirty="0" err="1">
-                <a:solidFill>
-                  <a:srgbClr val="F8FAFC"/>
-                </a:solidFill>
-                <a:latin typeface="Segoe UI" pitchFamily="34" charset="0"/>
-                <a:ea typeface="Segoe UI" pitchFamily="34" charset="-122"/>
-                <a:cs typeface="Segoe UI" pitchFamily="34" charset="-120"/>
-              </a:rPr>
-              <a:t>программирование</a:t>
+              <a:t>09.02.07 Информационные системы и программирование
+</a:t>
+            </a:r>
+            <a:pPr indent="0" marL="0">
+              <a:buNone/>
+            </a:pPr>
+            <a:r>
+              <a:rPr lang="en-US" sz="1000" dirty="0">
+                <a:solidFill>
+                  <a:srgbClr val="94A3B8"/>
+                </a:solidFill>
+                <a:latin typeface="Segoe UI" pitchFamily="34" charset="0"/>
+                <a:ea typeface="Segoe UI" pitchFamily="34" charset="-122"/>
+                <a:cs typeface="Segoe UI" pitchFamily="34" charset="-120"/>
+              </a:rPr>
+              <a:t>ПМ.02 «Осуществление интеграции программных модулей»</a:t>
             </a:r>
             <a:endParaRPr lang="en-US" sz="1000" dirty="0"/>
           </a:p>
@@ -2171,7 +2451,7 @@
           <a:bodyPr wrap="square" rtlCol="0" anchor="ctr"/>
           <a:lstStyle/>
           <a:p>
-            <a:pPr marL="0" indent="0">
+            <a:pPr indent="0" marL="0">
               <a:buNone/>
             </a:pPr>
             <a:r>
@@ -2186,6 +2466,9 @@
               <a:t>РАЗРАБОТЧИК И РЕЛИЗ
 </a:t>
             </a:r>
+            <a:pPr indent="0" marL="0">
+              <a:buNone/>
+            </a:pPr>
             <a:r>
               <a:rPr lang="en-US" sz="1100" b="1" dirty="0">
                 <a:solidFill>
@@ -2198,6 +2481,9 @@
               <a:t>Журавлёв М., студент группы ИСП-43
 </a:t>
             </a:r>
+            <a:pPr indent="0" marL="0">
+              <a:buNone/>
+            </a:pPr>
             <a:r>
               <a:rPr lang="en-US" sz="1000" dirty="0">
                 <a:solidFill>
@@ -2261,7 +2547,7 @@
           <a:bodyPr wrap="square" rtlCol="0" anchor="ctr"/>
           <a:lstStyle/>
           <a:p>
-            <a:pPr marL="0" indent="0" algn="ctr">
+            <a:pPr algn="ctr" indent="0" marL="0">
               <a:buNone/>
             </a:pPr>
             <a:r>
@@ -2327,7 +2613,7 @@
           <a:bodyPr wrap="square" rtlCol="0" anchor="ctr"/>
           <a:lstStyle/>
           <a:p>
-            <a:pPr marL="0" indent="0" algn="ctr">
+            <a:pPr algn="ctr" indent="0" marL="0">
               <a:buNone/>
             </a:pPr>
             <a:r>
@@ -2393,7 +2679,7 @@
           <a:bodyPr wrap="square" rtlCol="0" anchor="ctr"/>
           <a:lstStyle/>
           <a:p>
-            <a:pPr marL="0" indent="0" algn="ctr">
+            <a:pPr algn="ctr" indent="0" marL="0">
               <a:buNone/>
             </a:pPr>
             <a:r>
@@ -2459,7 +2745,7 @@
           <a:bodyPr wrap="square" rtlCol="0" anchor="ctr"/>
           <a:lstStyle/>
           <a:p>
-            <a:pPr marL="0" indent="0" algn="ctr">
+            <a:pPr algn="ctr" indent="0" marL="0">
               <a:buNone/>
             </a:pPr>
             <a:r>
@@ -2525,7 +2811,7 @@
           <a:bodyPr wrap="square" rtlCol="0" anchor="ctr"/>
           <a:lstStyle/>
           <a:p>
-            <a:pPr marL="0" indent="0" algn="ctr">
+            <a:pPr algn="ctr" indent="0" marL="0">
               <a:buNone/>
             </a:pPr>
             <a:r>
@@ -2591,7 +2877,7 @@
           <a:bodyPr wrap="square" rtlCol="0" anchor="ctr"/>
           <a:lstStyle/>
           <a:p>
-            <a:pPr marL="0" indent="0" algn="ctr">
+            <a:pPr algn="ctr" indent="0" marL="0">
               <a:buNone/>
             </a:pPr>
             <a:r>
@@ -2625,7 +2911,6 @@
         <a:solidFill>
           <a:srgbClr val="0B0F19"/>
         </a:solidFill>
-        <a:effectLst/>
       </p:bgPr>
     </p:bg>
     <p:spTree>
@@ -2663,7 +2948,7 @@
           <a:bodyPr wrap="square" rtlCol="0" anchor="ctr"/>
           <a:lstStyle/>
           <a:p>
-            <a:pPr marL="0" indent="0">
+            <a:pPr indent="0" marL="0">
               <a:buNone/>
             </a:pPr>
             <a:r>
@@ -2702,7 +2987,7 @@
           <a:bodyPr wrap="square" rtlCol="0" anchor="ctr"/>
           <a:lstStyle/>
           <a:p>
-            <a:pPr marL="0" indent="0">
+            <a:pPr indent="0" marL="0">
               <a:buNone/>
             </a:pPr>
             <a:r>
@@ -2791,7 +3076,7 @@
           <a:bodyPr wrap="square" rtlCol="0" anchor="ctr"/>
           <a:lstStyle/>
           <a:p>
-            <a:pPr marL="0" indent="0">
+            <a:pPr indent="0" marL="0">
               <a:buNone/>
             </a:pPr>
             <a:r>
@@ -2803,18 +3088,7 @@
                 <a:ea typeface="Segoe UI" pitchFamily="34" charset="-122"/>
                 <a:cs typeface="Segoe UI" pitchFamily="34" charset="-120"/>
               </a:rPr>
-              <a:t>StellarGenesis v1.0 • </a:t>
-            </a:r>
-            <a:r>
-              <a:rPr lang="ru-RU" sz="900" dirty="0">
-                <a:solidFill>
-                  <a:srgbClr val="64748B"/>
-                </a:solidFill>
-                <a:latin typeface="Segoe UI" pitchFamily="34" charset="0"/>
-                <a:ea typeface="Segoe UI" pitchFamily="34" charset="-122"/>
-                <a:cs typeface="Segoe UI" pitchFamily="34" charset="-120"/>
-              </a:rPr>
-              <a:t>Защита проекта учебной практики</a:t>
+              <a:t>StellarGenesis v1.0 • Защита проекта производственной практики</a:t>
             </a:r>
             <a:endParaRPr lang="en-US" sz="900" dirty="0"/>
           </a:p>
@@ -2841,7 +3115,7 @@
           <a:bodyPr wrap="square" rtlCol="0" anchor="ctr"/>
           <a:lstStyle/>
           <a:p>
-            <a:pPr marL="0" indent="0" algn="ctr">
+            <a:pPr algn="ctr" indent="0" marL="0">
               <a:buNone/>
             </a:pPr>
             <a:r>
@@ -2880,7 +3154,7 @@
           <a:bodyPr wrap="square" rtlCol="0" anchor="ctr"/>
           <a:lstStyle/>
           <a:p>
-            <a:pPr marL="0" indent="0" algn="r">
+            <a:pPr algn="r" indent="0" marL="0">
               <a:buNone/>
             </a:pPr>
             <a:r>
@@ -2946,7 +3220,7 @@
           <a:bodyPr wrap="square" rtlCol="0" anchor="ctr"/>
           <a:lstStyle/>
           <a:p>
-            <a:pPr marL="0" indent="0">
+            <a:pPr indent="0" marL="0">
               <a:buNone/>
             </a:pPr>
             <a:r>
@@ -2985,7 +3259,7 @@
           <a:bodyPr wrap="square" rtlCol="0" anchor="ctr"/>
           <a:lstStyle/>
           <a:p>
-            <a:pPr marL="0" indent="0">
+            <a:pPr indent="0" marL="0">
               <a:buNone/>
             </a:pPr>
             <a:r>
@@ -3000,6 +3274,9 @@
               <a:t>• NC-01: Ликвидация магических чисел
 </a:t>
             </a:r>
+            <a:pPr indent="0" marL="0">
+              <a:buNone/>
+            </a:pPr>
             <a:r>
               <a:rPr lang="en-US" sz="980" dirty="0">
                 <a:solidFill>
@@ -3012,6 +3289,9 @@
               <a:t>Вынесены константы ACCRETION_EFFICIENCY, SPEED_OF_LIGHT, CHANDRASEKHAR_LIMIT, MAX_SNAPSHOT_PARTICLES;
 </a:t>
             </a:r>
+            <a:pPr indent="0" marL="0">
+              <a:buNone/>
+            </a:pPr>
             <a:r>
               <a:rPr lang="en-US" sz="1050" b="1" dirty="0">
                 <a:solidFill>
@@ -3024,6 +3304,9 @@
               <a:t>• NC-02 &amp; NC-03: Декомпозиция монолита
 </a:t>
             </a:r>
+            <a:pPr indent="0" marL="0">
+              <a:buNone/>
+            </a:pPr>
             <a:r>
               <a:rPr lang="en-US" sz="980" dirty="0">
                 <a:solidFill>
@@ -3036,6 +3319,9 @@
               <a:t>Функция computeAccelerations декомпозирована со 160 до 40 строк, вынесен хелпер computeSingleBodyTidalStretch;
 </a:t>
             </a:r>
+            <a:pPr indent="0" marL="0">
+              <a:buNone/>
+            </a:pPr>
             <a:r>
               <a:rPr lang="en-US" sz="1050" b="1" dirty="0">
                 <a:solidFill>
@@ -3048,6 +3334,9 @@
               <a:t>• NC-04 &amp; NC-05: Стандартизация именования и TSDoc
 </a:t>
             </a:r>
+            <a:pPr indent="0" marL="0">
+              <a:buNone/>
+            </a:pPr>
             <a:r>
               <a:rPr lang="en-US" sz="980" dirty="0">
                 <a:solidFill>
@@ -3060,6 +3349,9 @@
               <a:t>100% публичных функций задокументированы TSDoc, устранены однобуквенные переменные (b -&gt; body);
 </a:t>
             </a:r>
+            <a:pPr indent="0" marL="0">
+              <a:buNone/>
+            </a:pPr>
             <a:r>
               <a:rPr lang="en-US" sz="1050" b="1" dirty="0">
                 <a:solidFill>
@@ -3072,6 +3364,9 @@
               <a:t>• NC-06: Защита браузерного Web Audio
 </a:t>
             </a:r>
+            <a:pPr indent="0" marL="0">
+              <a:buNone/>
+            </a:pPr>
             <a:r>
               <a:rPr lang="en-US" sz="980" dirty="0">
                 <a:solidFill>
@@ -3135,7 +3430,7 @@
           <a:bodyPr wrap="square" rtlCol="0" anchor="ctr"/>
           <a:lstStyle/>
           <a:p>
-            <a:pPr marL="0" indent="0">
+            <a:pPr indent="0" marL="0">
               <a:buNone/>
             </a:pPr>
             <a:r>
@@ -3155,14 +3450,14 @@
       </p:sp>
       <p:pic>
         <p:nvPicPr>
-          <p:cNvPr id="14" name="Image 0" descr="/app/applet/docs/screenshots/lighthouse.png"/>
+          <p:cNvPr id="14" name="Image 0" descr="/app/applet/docs/screenshots/lighthouse.png">    </p:cNvPr>
           <p:cNvPicPr>
             <a:picLocks noChangeAspect="1"/>
           </p:cNvPicPr>
           <p:nvPr/>
         </p:nvPicPr>
         <p:blipFill>
-          <a:blip r:embed="rId3"/>
+          <a:blip r:embed="rId1"/>
           <a:stretch>
             <a:fillRect/>
           </a:stretch>
@@ -3225,7 +3520,7 @@
           <a:bodyPr wrap="square" rtlCol="0" anchor="ctr"/>
           <a:lstStyle/>
           <a:p>
-            <a:pPr marL="0" indent="0" algn="ctr">
+            <a:pPr algn="ctr" indent="0" marL="0">
               <a:buNone/>
             </a:pPr>
             <a:r>
@@ -3242,7 +3537,7 @@
             <a:endParaRPr lang="en-US" sz="1000" dirty="0"/>
           </a:p>
           <a:p>
-            <a:pPr marL="0" indent="0" algn="ctr">
+            <a:pPr algn="ctr" indent="0" marL="0">
               <a:buNone/>
             </a:pPr>
             <a:r>
@@ -3276,7 +3571,6 @@
         <a:solidFill>
           <a:srgbClr val="0B0F19"/>
         </a:solidFill>
-        <a:effectLst/>
       </p:bgPr>
     </p:bg>
     <p:spTree>
@@ -3314,7 +3608,7 @@
           <a:bodyPr wrap="square" rtlCol="0" anchor="ctr"/>
           <a:lstStyle/>
           <a:p>
-            <a:pPr marL="0" indent="0">
+            <a:pPr indent="0" marL="0">
               <a:buNone/>
             </a:pPr>
             <a:r>
@@ -3353,7 +3647,7 @@
           <a:bodyPr wrap="square" rtlCol="0" anchor="ctr"/>
           <a:lstStyle/>
           <a:p>
-            <a:pPr marL="0" indent="0">
+            <a:pPr indent="0" marL="0">
               <a:buNone/>
             </a:pPr>
             <a:r>
@@ -3442,7 +3736,7 @@
           <a:bodyPr wrap="square" rtlCol="0" anchor="ctr"/>
           <a:lstStyle/>
           <a:p>
-            <a:pPr marL="0" indent="0">
+            <a:pPr indent="0" marL="0">
               <a:buNone/>
             </a:pPr>
             <a:r>
@@ -3454,18 +3748,7 @@
                 <a:ea typeface="Segoe UI" pitchFamily="34" charset="-122"/>
                 <a:cs typeface="Segoe UI" pitchFamily="34" charset="-120"/>
               </a:rPr>
-              <a:t>StellarGenesis v1.0 • </a:t>
-            </a:r>
-            <a:r>
-              <a:rPr lang="ru-RU" sz="900" dirty="0">
-                <a:solidFill>
-                  <a:srgbClr val="64748B"/>
-                </a:solidFill>
-                <a:latin typeface="Segoe UI" pitchFamily="34" charset="0"/>
-                <a:ea typeface="Segoe UI" pitchFamily="34" charset="-122"/>
-                <a:cs typeface="Segoe UI" pitchFamily="34" charset="-120"/>
-              </a:rPr>
-              <a:t>Защита проекта учебной практики</a:t>
+              <a:t>StellarGenesis v1.0 • Защита проекта производственной практики</a:t>
             </a:r>
             <a:endParaRPr lang="en-US" sz="900" dirty="0"/>
           </a:p>
@@ -3492,7 +3775,7 @@
           <a:bodyPr wrap="square" rtlCol="0" anchor="ctr"/>
           <a:lstStyle/>
           <a:p>
-            <a:pPr marL="0" indent="0" algn="ctr">
+            <a:pPr algn="ctr" indent="0" marL="0">
               <a:buNone/>
             </a:pPr>
             <a:r>
@@ -3531,7 +3814,7 @@
           <a:bodyPr wrap="square" rtlCol="0" anchor="ctr"/>
           <a:lstStyle/>
           <a:p>
-            <a:pPr marL="0" indent="0" algn="r">
+            <a:pPr algn="r" indent="0" marL="0">
               <a:buNone/>
             </a:pPr>
             <a:r>
@@ -3597,7 +3880,7 @@
           <a:bodyPr wrap="square" rtlCol="0" anchor="ctr"/>
           <a:lstStyle/>
           <a:p>
-            <a:pPr marL="0" indent="0">
+            <a:pPr indent="0" marL="0">
               <a:buNone/>
             </a:pPr>
             <a:r>
@@ -3636,7 +3919,7 @@
           <a:bodyPr wrap="square" rtlCol="0" anchor="ctr"/>
           <a:lstStyle/>
           <a:p>
-            <a:pPr marL="0" indent="0">
+            <a:pPr indent="0" marL="0">
               <a:buNone/>
             </a:pPr>
             <a:r>
@@ -3651,6 +3934,9 @@
               <a:t>Структура веток в репозитории:
 </a:t>
             </a:r>
+            <a:pPr indent="0" marL="0">
+              <a:buNone/>
+            </a:pPr>
             <a:r>
               <a:rPr lang="en-US" sz="1000" dirty="0">
                 <a:solidFill>
@@ -3667,6 +3953,9 @@
 • release/v1.0 — стабилизация релизного билда.
 </a:t>
             </a:r>
+            <a:pPr indent="0" marL="0">
+              <a:buNone/>
+            </a:pPr>
             <a:r>
               <a:rPr lang="en-US" sz="1100" b="1" dirty="0">
                 <a:solidFill>
@@ -3679,6 +3968,9 @@
               <a:t>Разрешение конфликта слияния (Merge Conflict):
 </a:t>
             </a:r>
+            <a:pPr indent="0" marL="0">
+              <a:buNone/>
+            </a:pPr>
             <a:r>
               <a:rPr lang="en-US" sz="1000" dirty="0">
                 <a:solidFill>
@@ -3691,6 +3983,9 @@
               <a:t>В файле src/physics/engine.ts смоделирован и успешно разрешен конфликт при интеграции TDE и Доплера коммитом 5b7e31d без потери функционала.
 </a:t>
             </a:r>
+            <a:pPr indent="0" marL="0">
+              <a:buNone/>
+            </a:pPr>
             <a:r>
               <a:rPr lang="en-US" sz="1100" b="1" dirty="0">
                 <a:solidFill>
@@ -3703,6 +3998,9 @@
               <a:t>Официальный релиз:
 </a:t>
             </a:r>
+            <a:pPr indent="0" marL="0">
+              <a:buNone/>
+            </a:pPr>
             <a:r>
               <a:rPr lang="en-US" sz="1000" dirty="0">
                 <a:solidFill>
@@ -3766,7 +4064,7 @@
           <a:bodyPr wrap="square" rtlCol="0" anchor="ctr"/>
           <a:lstStyle/>
           <a:p>
-            <a:pPr marL="0" indent="0">
+            <a:pPr indent="0" marL="0">
               <a:buNone/>
             </a:pPr>
             <a:r>
@@ -3786,14 +4084,14 @@
       </p:sp>
       <p:pic>
         <p:nvPicPr>
-          <p:cNvPr id="14" name="Image 0" descr="/app/applet/docs/screenshots/git-graph.png"/>
+          <p:cNvPr id="14" name="Image 0" descr="/app/applet/docs/screenshots/git-graph.png">    </p:cNvPr>
           <p:cNvPicPr>
             <a:picLocks noChangeAspect="1"/>
           </p:cNvPicPr>
           <p:nvPr/>
         </p:nvPicPr>
         <p:blipFill>
-          <a:blip r:embed="rId3"/>
+          <a:blip r:embed="rId1"/>
           <a:stretch>
             <a:fillRect/>
           </a:stretch>
@@ -3856,7 +4154,7 @@
           <a:bodyPr wrap="square" rtlCol="0" anchor="ctr"/>
           <a:lstStyle/>
           <a:p>
-            <a:pPr marL="0" indent="0" algn="ctr">
+            <a:pPr algn="ctr" indent="0" marL="0">
               <a:buNone/>
             </a:pPr>
             <a:r>
@@ -3873,7 +4171,7 @@
             <a:endParaRPr lang="en-US" sz="1000" dirty="0"/>
           </a:p>
           <a:p>
-            <a:pPr marL="0" indent="0" algn="ctr">
+            <a:pPr algn="ctr" indent="0" marL="0">
               <a:buNone/>
             </a:pPr>
             <a:r>
@@ -3907,7 +4205,6 @@
         <a:solidFill>
           <a:srgbClr val="0B0F19"/>
         </a:solidFill>
-        <a:effectLst/>
       </p:bgPr>
     </p:bg>
     <p:spTree>
@@ -3945,7 +4242,7 @@
           <a:bodyPr wrap="square" rtlCol="0" anchor="ctr"/>
           <a:lstStyle/>
           <a:p>
-            <a:pPr marL="0" indent="0">
+            <a:pPr indent="0" marL="0">
               <a:buNone/>
             </a:pPr>
             <a:r>
@@ -3984,7 +4281,7 @@
           <a:bodyPr wrap="square" rtlCol="0" anchor="ctr"/>
           <a:lstStyle/>
           <a:p>
-            <a:pPr marL="0" indent="0">
+            <a:pPr indent="0" marL="0">
               <a:buNone/>
             </a:pPr>
             <a:r>
@@ -4073,7 +4370,7 @@
           <a:bodyPr wrap="square" rtlCol="0" anchor="ctr"/>
           <a:lstStyle/>
           <a:p>
-            <a:pPr marL="0" indent="0">
+            <a:pPr indent="0" marL="0">
               <a:buNone/>
             </a:pPr>
             <a:r>
@@ -4085,18 +4382,7 @@
                 <a:ea typeface="Segoe UI" pitchFamily="34" charset="-122"/>
                 <a:cs typeface="Segoe UI" pitchFamily="34" charset="-120"/>
               </a:rPr>
-              <a:t>StellarGenesis v1.0 • </a:t>
-            </a:r>
-            <a:r>
-              <a:rPr lang="ru-RU" sz="900" dirty="0">
-                <a:solidFill>
-                  <a:srgbClr val="64748B"/>
-                </a:solidFill>
-                <a:latin typeface="Segoe UI" pitchFamily="34" charset="0"/>
-                <a:ea typeface="Segoe UI" pitchFamily="34" charset="-122"/>
-                <a:cs typeface="Segoe UI" pitchFamily="34" charset="-120"/>
-              </a:rPr>
-              <a:t>Защита проекта учебной практики</a:t>
+              <a:t>StellarGenesis v1.0 • Защита проекта производственной практики</a:t>
             </a:r>
             <a:endParaRPr lang="en-US" sz="900" dirty="0"/>
           </a:p>
@@ -4123,7 +4409,7 @@
           <a:bodyPr wrap="square" rtlCol="0" anchor="ctr"/>
           <a:lstStyle/>
           <a:p>
-            <a:pPr marL="0" indent="0" algn="ctr">
+            <a:pPr algn="ctr" indent="0" marL="0">
               <a:buNone/>
             </a:pPr>
             <a:r>
@@ -4162,7 +4448,7 @@
           <a:bodyPr wrap="square" rtlCol="0" anchor="ctr"/>
           <a:lstStyle/>
           <a:p>
-            <a:pPr marL="0" indent="0" algn="r">
+            <a:pPr algn="r" indent="0" marL="0">
               <a:buNone/>
             </a:pPr>
             <a:r>
@@ -4228,7 +4514,7 @@
           <a:bodyPr wrap="square" rtlCol="0" anchor="ctr"/>
           <a:lstStyle/>
           <a:p>
-            <a:pPr marL="0" indent="0">
+            <a:pPr indent="0" marL="0">
               <a:buNone/>
             </a:pPr>
             <a:r>
@@ -4267,7 +4553,7 @@
           <a:bodyPr wrap="square" rtlCol="0" anchor="ctr"/>
           <a:lstStyle/>
           <a:p>
-            <a:pPr marL="0" indent="0">
+            <a:pPr indent="0" marL="0">
               <a:buNone/>
             </a:pPr>
             <a:r>
@@ -4333,7 +4619,7 @@
           <a:bodyPr wrap="square" rtlCol="0" anchor="ctr"/>
           <a:lstStyle/>
           <a:p>
-            <a:pPr marL="0" indent="0">
+            <a:pPr indent="0" marL="0">
               <a:buNone/>
             </a:pPr>
             <a:r>
@@ -4372,7 +4658,7 @@
           <a:bodyPr wrap="square" rtlCol="0" anchor="ctr"/>
           <a:lstStyle/>
           <a:p>
-            <a:pPr marL="0" indent="0">
+            <a:pPr indent="0" marL="0">
               <a:buNone/>
             </a:pPr>
             <a:r>
@@ -4438,7 +4724,7 @@
           <a:bodyPr wrap="square" rtlCol="0" anchor="ctr"/>
           <a:lstStyle/>
           <a:p>
-            <a:pPr marL="0" indent="0">
+            <a:pPr indent="0" marL="0">
               <a:buNone/>
             </a:pPr>
             <a:r>
@@ -4477,7 +4763,7 @@
           <a:bodyPr wrap="square" rtlCol="0" anchor="ctr"/>
           <a:lstStyle/>
           <a:p>
-            <a:pPr marL="0" indent="0">
+            <a:pPr indent="0" marL="0">
               <a:buNone/>
             </a:pPr>
             <a:r>
@@ -4543,7 +4829,7 @@
           <a:bodyPr wrap="square" rtlCol="0" anchor="ctr"/>
           <a:lstStyle/>
           <a:p>
-            <a:pPr marL="0" indent="0">
+            <a:pPr indent="0" marL="0">
               <a:buNone/>
             </a:pPr>
             <a:r>
@@ -4582,7 +4868,7 @@
           <a:bodyPr wrap="square" rtlCol="0" anchor="ctr"/>
           <a:lstStyle/>
           <a:p>
-            <a:pPr marL="0" indent="0">
+            <a:pPr indent="0" marL="0">
               <a:buNone/>
             </a:pPr>
             <a:r>
@@ -4648,7 +4934,7 @@
           <a:bodyPr wrap="square" rtlCol="0" anchor="ctr"/>
           <a:lstStyle/>
           <a:p>
-            <a:pPr marL="0" indent="0">
+            <a:pPr indent="0" marL="0">
               <a:buNone/>
             </a:pPr>
             <a:r>
@@ -4687,7 +4973,7 @@
           <a:bodyPr wrap="square" rtlCol="0" anchor="ctr"/>
           <a:lstStyle/>
           <a:p>
-            <a:pPr marL="0" indent="0">
+            <a:pPr indent="0" marL="0">
               <a:buNone/>
             </a:pPr>
             <a:r>
@@ -4753,7 +5039,7 @@
           <a:bodyPr wrap="square" rtlCol="0" anchor="ctr"/>
           <a:lstStyle/>
           <a:p>
-            <a:pPr marL="0" indent="0">
+            <a:pPr indent="0" marL="0">
               <a:buNone/>
             </a:pPr>
             <a:r>
@@ -4792,7 +5078,7 @@
           <a:bodyPr wrap="square" rtlCol="0" anchor="ctr"/>
           <a:lstStyle/>
           <a:p>
-            <a:pPr marL="0" indent="0">
+            <a:pPr indent="0" marL="0">
               <a:buNone/>
             </a:pPr>
             <a:r>
@@ -4826,7 +5112,6 @@
         <a:solidFill>
           <a:srgbClr val="0B0F19"/>
         </a:solidFill>
-        <a:effectLst/>
       </p:bgPr>
     </p:bg>
     <p:spTree>
@@ -4864,7 +5149,7 @@
           <a:bodyPr wrap="square" rtlCol="0" anchor="ctr"/>
           <a:lstStyle/>
           <a:p>
-            <a:pPr marL="0" indent="0">
+            <a:pPr indent="0" marL="0">
               <a:buNone/>
             </a:pPr>
             <a:r>
@@ -4903,7 +5188,7 @@
           <a:bodyPr wrap="square" rtlCol="0" anchor="ctr"/>
           <a:lstStyle/>
           <a:p>
-            <a:pPr marL="0" indent="0">
+            <a:pPr indent="0" marL="0">
               <a:buNone/>
             </a:pPr>
             <a:r>
@@ -4992,7 +5277,7 @@
           <a:bodyPr wrap="square" rtlCol="0" anchor="ctr"/>
           <a:lstStyle/>
           <a:p>
-            <a:pPr marL="0" indent="0">
+            <a:pPr indent="0" marL="0">
               <a:buNone/>
             </a:pPr>
             <a:r>
@@ -5004,18 +5289,7 @@
                 <a:ea typeface="Segoe UI" pitchFamily="34" charset="-122"/>
                 <a:cs typeface="Segoe UI" pitchFamily="34" charset="-120"/>
               </a:rPr>
-              <a:t>StellarGenesis v1.0 • </a:t>
-            </a:r>
-            <a:r>
-              <a:rPr lang="ru-RU" sz="900" dirty="0">
-                <a:solidFill>
-                  <a:srgbClr val="64748B"/>
-                </a:solidFill>
-                <a:latin typeface="Segoe UI" pitchFamily="34" charset="0"/>
-                <a:ea typeface="Segoe UI" pitchFamily="34" charset="-122"/>
-                <a:cs typeface="Segoe UI" pitchFamily="34" charset="-120"/>
-              </a:rPr>
-              <a:t>Защита проекта учебной практики</a:t>
+              <a:t>StellarGenesis v1.0 • Защита проекта производственной практики</a:t>
             </a:r>
             <a:endParaRPr lang="en-US" sz="900" dirty="0"/>
           </a:p>
@@ -5042,7 +5316,7 @@
           <a:bodyPr wrap="square" rtlCol="0" anchor="ctr"/>
           <a:lstStyle/>
           <a:p>
-            <a:pPr marL="0" indent="0" algn="ctr">
+            <a:pPr algn="ctr" indent="0" marL="0">
               <a:buNone/>
             </a:pPr>
             <a:r>
@@ -5081,7 +5355,7 @@
           <a:bodyPr wrap="square" rtlCol="0" anchor="ctr"/>
           <a:lstStyle/>
           <a:p>
-            <a:pPr marL="0" indent="0" algn="r">
+            <a:pPr algn="r" indent="0" marL="0">
               <a:buNone/>
             </a:pPr>
             <a:r>
@@ -5147,7 +5421,7 @@
           <a:bodyPr wrap="square" rtlCol="0" anchor="ctr"/>
           <a:lstStyle/>
           <a:p>
-            <a:pPr marL="0" indent="0">
+            <a:pPr indent="0" marL="0">
               <a:buNone/>
             </a:pPr>
             <a:r>
@@ -5186,7 +5460,7 @@
           <a:bodyPr wrap="square" rtlCol="0" anchor="ctr"/>
           <a:lstStyle/>
           <a:p>
-            <a:pPr marL="0" indent="0">
+            <a:pPr indent="0" marL="0">
               <a:buNone/>
             </a:pPr>
             <a:r>
@@ -5201,6 +5475,9 @@
               <a:t>✔ Научно достоверный астрофизический симулятор
 </a:t>
             </a:r>
+            <a:pPr indent="0" marL="0">
+              <a:buNone/>
+            </a:pPr>
             <a:r>
               <a:rPr lang="en-US" sz="980" dirty="0">
                 <a:solidFill>
@@ -5213,6 +5490,9 @@
               <a:t>Реализованы задачи N-тел, гидростатика нуклеосинтеза, приливная спагеттификация и релятивистский эффект Доплера.
 </a:t>
             </a:r>
+            <a:pPr indent="0" marL="0">
+              <a:buNone/>
+            </a:pPr>
             <a:r>
               <a:rPr lang="en-US" sz="1050" b="1" dirty="0">
                 <a:solidFill>
@@ -5225,6 +5505,9 @@
               <a:t>✔ Уникальная веб-визуализация на WebGL 2.0
 </a:t>
             </a:r>
+            <a:pPr indent="0" marL="0">
+              <a:buNone/>
+            </a:pPr>
             <a:r>
               <a:rPr lang="en-US" sz="980" dirty="0">
                 <a:solidFill>
@@ -5237,6 +5520,9 @@
               <a:t>Аналитический шейдер линзирования Эйнштейна исполняется на GPU в реальном времени при стабильных 60 FPS.
 </a:t>
             </a:r>
+            <a:pPr indent="0" marL="0">
+              <a:buNone/>
+            </a:pPr>
             <a:r>
               <a:rPr lang="en-US" sz="1050" b="1" dirty="0">
                 <a:solidFill>
@@ -5249,6 +5535,9 @@
               <a:t>✔ Высокая надежность и чистота кодовой базы
 </a:t>
             </a:r>
+            <a:pPr indent="0" marL="0">
+              <a:buNone/>
+            </a:pPr>
             <a:r>
               <a:rPr lang="en-US" sz="980" dirty="0">
                 <a:solidFill>
@@ -5261,6 +5550,9 @@
               <a:t>38 unit-тестов Vitest, 0 ошибок линтинга TypeScript, 100% покрытие TSDoc, аудит Google Lighthouse 98–100.
 </a:t>
             </a:r>
+            <a:pPr indent="0" marL="0">
+              <a:buNone/>
+            </a:pPr>
             <a:r>
               <a:rPr lang="en-US" sz="1050" b="1" dirty="0">
                 <a:solidFill>
@@ -5273,6 +5565,9 @@
               <a:t>✔ Исчерпывающая эксплуатационная документация
 </a:t>
             </a:r>
+            <a:pPr indent="0" marL="0">
+              <a:buNone/>
+            </a:pPr>
             <a:r>
               <a:rPr lang="en-US" sz="980" dirty="0">
                 <a:solidFill>
@@ -5336,7 +5631,7 @@
           <a:bodyPr wrap="square" rtlCol="0" anchor="ctr"/>
           <a:lstStyle/>
           <a:p>
-            <a:pPr marL="0" indent="0">
+            <a:pPr indent="0" marL="0">
               <a:buNone/>
             </a:pPr>
             <a:r>
@@ -5356,14 +5651,14 @@
       </p:sp>
       <p:pic>
         <p:nvPicPr>
-          <p:cNvPr id="14" name="Image 0" descr="/app/applet/docs/screenshots/network.png"/>
+          <p:cNvPr id="14" name="Image 0" descr="/app/applet/docs/screenshots/network.png">    </p:cNvPr>
           <p:cNvPicPr>
             <a:picLocks noChangeAspect="1"/>
           </p:cNvPicPr>
           <p:nvPr/>
         </p:nvPicPr>
         <p:blipFill>
-          <a:blip r:embed="rId3"/>
+          <a:blip r:embed="rId1"/>
           <a:stretch>
             <a:fillRect/>
           </a:stretch>
@@ -5426,7 +5721,7 @@
           <a:bodyPr wrap="square" rtlCol="0" anchor="ctr"/>
           <a:lstStyle/>
           <a:p>
-            <a:pPr marL="0" indent="0" algn="ctr">
+            <a:pPr algn="ctr" indent="0" marL="0">
               <a:buNone/>
             </a:pPr>
             <a:r>
@@ -5443,7 +5738,7 @@
             <a:endParaRPr lang="en-US" sz="1000" dirty="0"/>
           </a:p>
           <a:p>
-            <a:pPr marL="0" indent="0" algn="ctr">
+            <a:pPr algn="ctr" indent="0" marL="0">
               <a:buNone/>
             </a:pPr>
             <a:r>
@@ -5477,7 +5772,6 @@
         <a:solidFill>
           <a:srgbClr val="0B0F19"/>
         </a:solidFill>
-        <a:effectLst/>
       </p:bgPr>
     </p:bg>
     <p:spTree>
@@ -5515,7 +5809,7 @@
           <a:bodyPr wrap="square" rtlCol="0" anchor="ctr"/>
           <a:lstStyle/>
           <a:p>
-            <a:pPr marL="0" indent="0">
+            <a:pPr indent="0" marL="0">
               <a:buNone/>
             </a:pPr>
             <a:r>
@@ -5554,7 +5848,7 @@
           <a:bodyPr wrap="square" rtlCol="0" anchor="ctr"/>
           <a:lstStyle/>
           <a:p>
-            <a:pPr marL="0" indent="0">
+            <a:pPr indent="0" marL="0">
               <a:buNone/>
             </a:pPr>
             <a:r>
@@ -5643,7 +5937,7 @@
           <a:bodyPr wrap="square" rtlCol="0" anchor="ctr"/>
           <a:lstStyle/>
           <a:p>
-            <a:pPr marL="0" indent="0">
+            <a:pPr indent="0" marL="0">
               <a:buNone/>
             </a:pPr>
             <a:r>
@@ -5655,18 +5949,7 @@
                 <a:ea typeface="Segoe UI" pitchFamily="34" charset="-122"/>
                 <a:cs typeface="Segoe UI" pitchFamily="34" charset="-120"/>
               </a:rPr>
-              <a:t>StellarGenesis v1.0 • </a:t>
-            </a:r>
-            <a:r>
-              <a:rPr lang="ru-RU" sz="900" dirty="0">
-                <a:solidFill>
-                  <a:srgbClr val="64748B"/>
-                </a:solidFill>
-                <a:latin typeface="Segoe UI" pitchFamily="34" charset="0"/>
-                <a:ea typeface="Segoe UI" pitchFamily="34" charset="-122"/>
-                <a:cs typeface="Segoe UI" pitchFamily="34" charset="-120"/>
-              </a:rPr>
-              <a:t>Защита проекта учебной практики</a:t>
+              <a:t>StellarGenesis v1.0 • Защита проекта производственной практики</a:t>
             </a:r>
             <a:endParaRPr lang="en-US" sz="900" dirty="0"/>
           </a:p>
@@ -5693,7 +5976,7 @@
           <a:bodyPr wrap="square" rtlCol="0" anchor="ctr"/>
           <a:lstStyle/>
           <a:p>
-            <a:pPr marL="0" indent="0" algn="ctr">
+            <a:pPr algn="ctr" indent="0" marL="0">
               <a:buNone/>
             </a:pPr>
             <a:r>
@@ -5732,7 +6015,7 @@
           <a:bodyPr wrap="square" rtlCol="0" anchor="ctr"/>
           <a:lstStyle/>
           <a:p>
-            <a:pPr marL="0" indent="0" algn="r">
+            <a:pPr algn="r" indent="0" marL="0">
               <a:buNone/>
             </a:pPr>
             <a:r>
@@ -5798,7 +6081,7 @@
           <a:bodyPr wrap="square" rtlCol="0" anchor="ctr"/>
           <a:lstStyle/>
           <a:p>
-            <a:pPr marL="0" indent="0">
+            <a:pPr indent="0" marL="0">
               <a:buNone/>
             </a:pPr>
             <a:r>
@@ -5837,7 +6120,7 @@
           <a:bodyPr wrap="square" rtlCol="0" anchor="ctr"/>
           <a:lstStyle/>
           <a:p>
-            <a:pPr marL="0" indent="0">
+            <a:pPr indent="0" marL="0">
               <a:buNone/>
             </a:pPr>
             <a:r>
@@ -5854,7 +6137,7 @@
             <a:endParaRPr lang="en-US" sz="1020" dirty="0"/>
           </a:p>
           <a:p>
-            <a:pPr marL="0" indent="0">
+            <a:pPr indent="0" marL="0">
               <a:buNone/>
             </a:pPr>
             <a:r>
@@ -5920,7 +6203,7 @@
           <a:bodyPr wrap="square" rtlCol="0" anchor="ctr"/>
           <a:lstStyle/>
           <a:p>
-            <a:pPr marL="0" indent="0">
+            <a:pPr indent="0" marL="0">
               <a:buNone/>
             </a:pPr>
             <a:r>
@@ -5959,7 +6242,7 @@
           <a:bodyPr wrap="square" rtlCol="0" anchor="ctr"/>
           <a:lstStyle/>
           <a:p>
-            <a:pPr marL="0" indent="0">
+            <a:pPr indent="0" marL="0">
               <a:buNone/>
             </a:pPr>
             <a:r>
@@ -5976,7 +6259,7 @@
             <a:endParaRPr lang="en-US" sz="1020" dirty="0"/>
           </a:p>
           <a:p>
-            <a:pPr marL="0" indent="0">
+            <a:pPr indent="0" marL="0">
               <a:buNone/>
             </a:pPr>
             <a:r>
@@ -6042,7 +6325,7 @@
           <a:bodyPr wrap="square" rtlCol="0" anchor="ctr"/>
           <a:lstStyle/>
           <a:p>
-            <a:pPr marL="0" indent="0">
+            <a:pPr indent="0" marL="0">
               <a:buNone/>
             </a:pPr>
             <a:r>
@@ -6081,7 +6364,7 @@
           <a:bodyPr wrap="square" rtlCol="0" anchor="ctr"/>
           <a:lstStyle/>
           <a:p>
-            <a:pPr marL="0" indent="0">
+            <a:pPr indent="0" marL="0">
               <a:buNone/>
             </a:pPr>
             <a:r>
@@ -6098,7 +6381,7 @@
             <a:endParaRPr lang="en-US" sz="1020" dirty="0"/>
           </a:p>
           <a:p>
-            <a:pPr marL="0" indent="0">
+            <a:pPr indent="0" marL="0">
               <a:buNone/>
             </a:pPr>
             <a:r>
@@ -6132,7 +6415,6 @@
         <a:solidFill>
           <a:srgbClr val="0B0F19"/>
         </a:solidFill>
-        <a:effectLst/>
       </p:bgPr>
     </p:bg>
     <p:spTree>
@@ -6197,7 +6479,7 @@
           <a:bodyPr wrap="square" rtlCol="0" anchor="ctr"/>
           <a:lstStyle/>
           <a:p>
-            <a:pPr marL="0" indent="0" algn="ctr">
+            <a:pPr algn="ctr" indent="0" marL="0">
               <a:buNone/>
             </a:pPr>
             <a:r>
@@ -6236,7 +6518,7 @@
           <a:bodyPr wrap="square" rtlCol="0" anchor="ctr"/>
           <a:lstStyle/>
           <a:p>
-            <a:pPr marL="0" indent="0" algn="ctr">
+            <a:pPr algn="ctr" indent="0" marL="0">
               <a:buNone/>
             </a:pPr>
             <a:r>
@@ -6275,7 +6557,7 @@
           <a:bodyPr wrap="square" rtlCol="0" anchor="ctr"/>
           <a:lstStyle/>
           <a:p>
-            <a:pPr marL="0" indent="0" algn="ctr">
+            <a:pPr algn="ctr" indent="0" marL="0">
               <a:buNone/>
             </a:pPr>
             <a:r>
@@ -6361,7 +6643,7 @@
           <a:bodyPr wrap="square" rtlCol="0" anchor="ctr"/>
           <a:lstStyle/>
           <a:p>
-            <a:pPr marL="0" indent="0" algn="ctr">
+            <a:pPr algn="ctr" indent="0" marL="0">
               <a:buNone/>
             </a:pPr>
             <a:r>
@@ -6400,7 +6682,7 @@
           <a:bodyPr wrap="square" rtlCol="0" anchor="ctr"/>
           <a:lstStyle/>
           <a:p>
-            <a:pPr marL="0" indent="0" algn="ctr">
+            <a:pPr algn="ctr" indent="0" marL="0">
               <a:buNone/>
             </a:pPr>
             <a:r>
@@ -6439,7 +6721,7 @@
           <a:bodyPr wrap="square" rtlCol="0" anchor="ctr"/>
           <a:lstStyle/>
           <a:p>
-            <a:pPr marL="0" indent="0" algn="ctr">
+            <a:pPr algn="ctr" indent="0" marL="0">
               <a:buNone/>
             </a:pPr>
             <a:r>
@@ -6505,7 +6787,7 @@
           <a:bodyPr wrap="square" rtlCol="0" anchor="ctr"/>
           <a:lstStyle/>
           <a:p>
-            <a:pPr marL="0" indent="0" algn="ctr">
+            <a:pPr algn="ctr" indent="0" marL="0">
               <a:buNone/>
             </a:pPr>
             <a:r>
@@ -6544,7 +6826,7 @@
           <a:bodyPr wrap="square" rtlCol="0" anchor="ctr"/>
           <a:lstStyle/>
           <a:p>
-            <a:pPr marL="0" indent="0" algn="ctr">
+            <a:pPr algn="ctr" indent="0" marL="0">
               <a:buNone/>
             </a:pPr>
             <a:r>
@@ -6583,7 +6865,7 @@
           <a:bodyPr wrap="square" rtlCol="0" anchor="ctr"/>
           <a:lstStyle/>
           <a:p>
-            <a:pPr marL="0" indent="0" algn="ctr">
+            <a:pPr algn="ctr" indent="0" marL="0">
               <a:buNone/>
             </a:pPr>
             <a:r>
@@ -6649,7 +6931,7 @@
           <a:bodyPr wrap="square" rtlCol="0" anchor="ctr"/>
           <a:lstStyle/>
           <a:p>
-            <a:pPr marL="0" indent="0" algn="ctr">
+            <a:pPr algn="ctr" indent="0" marL="0">
               <a:buNone/>
             </a:pPr>
             <a:r>
@@ -6688,11 +6970,11 @@
           <a:bodyPr wrap="square" rtlCol="0" anchor="ctr"/>
           <a:lstStyle/>
           <a:p>
-            <a:pPr marL="0" indent="0" algn="ctr">
-              <a:buNone/>
-            </a:pPr>
-            <a:r>
-              <a:rPr lang="en-US" sz="1100" b="1" dirty="0" err="1">
+            <a:pPr algn="ctr" indent="0" marL="0">
+              <a:buNone/>
+            </a:pPr>
+            <a:r>
+              <a:rPr lang="en-US" sz="1100" b="1" dirty="0">
                 <a:solidFill>
                   <a:srgbClr val="F8FAFC"/>
                 </a:solidFill>
@@ -6700,40 +6982,7 @@
                 <a:ea typeface="Segoe UI" pitchFamily="34" charset="-122"/>
                 <a:cs typeface="Segoe UI" pitchFamily="34" charset="-120"/>
               </a:rPr>
-              <a:t>Журавлёв</a:t>
-            </a:r>
-            <a:r>
-              <a:rPr lang="en-US" sz="1100" b="1" dirty="0">
-                <a:solidFill>
-                  <a:srgbClr val="F8FAFC"/>
-                </a:solidFill>
-                <a:latin typeface="Segoe UI" pitchFamily="34" charset="0"/>
-                <a:ea typeface="Segoe UI" pitchFamily="34" charset="-122"/>
-                <a:cs typeface="Segoe UI" pitchFamily="34" charset="-120"/>
-              </a:rPr>
-              <a:t> </a:t>
-            </a:r>
-            <a:r>
-              <a:rPr lang="ru-RU" sz="1100" b="1" dirty="0">
-                <a:solidFill>
-                  <a:srgbClr val="F8FAFC"/>
-                </a:solidFill>
-                <a:latin typeface="Segoe UI" pitchFamily="34" charset="0"/>
-                <a:ea typeface="Segoe UI" pitchFamily="34" charset="-122"/>
-                <a:cs typeface="Segoe UI" pitchFamily="34" charset="-120"/>
-              </a:rPr>
-              <a:t>Максим</a:t>
-            </a:r>
-            <a:r>
-              <a:rPr lang="en-US" sz="1100" b="1" dirty="0">
-                <a:solidFill>
-                  <a:srgbClr val="F8FAFC"/>
-                </a:solidFill>
-                <a:latin typeface="Segoe UI" pitchFamily="34" charset="0"/>
-                <a:ea typeface="Segoe UI" pitchFamily="34" charset="-122"/>
-                <a:cs typeface="Segoe UI" pitchFamily="34" charset="-120"/>
-              </a:rPr>
-              <a:t> (ИСП-43)</a:t>
+              <a:t>Журавлёв Михаил (ИСП-43)</a:t>
             </a:r>
             <a:endParaRPr lang="en-US" sz="1100" dirty="0"/>
           </a:p>
@@ -6760,7 +7009,7 @@
           <a:bodyPr wrap="square" rtlCol="0" anchor="ctr"/>
           <a:lstStyle/>
           <a:p>
-            <a:pPr marL="0" indent="0" algn="ctr">
+            <a:pPr algn="ctr" indent="0" marL="0">
               <a:buNone/>
             </a:pPr>
             <a:r>
@@ -6777,7 +7026,7 @@
             <a:endParaRPr lang="en-US" sz="950" dirty="0"/>
           </a:p>
           <a:p>
-            <a:pPr marL="0" indent="0" algn="ctr">
+            <a:pPr algn="ctr" indent="0" marL="0">
               <a:buNone/>
             </a:pPr>
             <a:r>
@@ -6816,7 +7065,7 @@
           <a:bodyPr wrap="square" rtlCol="0" anchor="ctr"/>
           <a:lstStyle/>
           <a:p>
-            <a:pPr marL="0" indent="0" algn="ctr">
+            <a:pPr algn="ctr" indent="0" marL="0">
               <a:buNone/>
             </a:pPr>
             <a:r>
@@ -6850,7 +7099,6 @@
         <a:solidFill>
           <a:srgbClr val="0B0F19"/>
         </a:solidFill>
-        <a:effectLst/>
       </p:bgPr>
     </p:bg>
     <p:spTree>
@@ -6888,7 +7136,7 @@
           <a:bodyPr wrap="square" rtlCol="0" anchor="ctr"/>
           <a:lstStyle/>
           <a:p>
-            <a:pPr marL="0" indent="0">
+            <a:pPr indent="0" marL="0">
               <a:buNone/>
             </a:pPr>
             <a:r>
@@ -6927,7 +7175,7 @@
           <a:bodyPr wrap="square" rtlCol="0" anchor="ctr"/>
           <a:lstStyle/>
           <a:p>
-            <a:pPr marL="0" indent="0">
+            <a:pPr indent="0" marL="0">
               <a:buNone/>
             </a:pPr>
             <a:r>
@@ -7016,7 +7264,7 @@
           <a:bodyPr wrap="square" rtlCol="0" anchor="ctr"/>
           <a:lstStyle/>
           <a:p>
-            <a:pPr marL="0" indent="0">
+            <a:pPr indent="0" marL="0">
               <a:buNone/>
             </a:pPr>
             <a:r>
@@ -7028,18 +7276,7 @@
                 <a:ea typeface="Segoe UI" pitchFamily="34" charset="-122"/>
                 <a:cs typeface="Segoe UI" pitchFamily="34" charset="-120"/>
               </a:rPr>
-              <a:t>StellarGenesis v1.0 • </a:t>
-            </a:r>
-            <a:r>
-              <a:rPr lang="ru-RU" sz="900" dirty="0">
-                <a:solidFill>
-                  <a:srgbClr val="64748B"/>
-                </a:solidFill>
-                <a:latin typeface="Segoe UI" pitchFamily="34" charset="0"/>
-                <a:ea typeface="Segoe UI" pitchFamily="34" charset="-122"/>
-                <a:cs typeface="Segoe UI" pitchFamily="34" charset="-120"/>
-              </a:rPr>
-              <a:t>Защита проекта учебной практики</a:t>
+              <a:t>StellarGenesis v1.0 • Защита проекта производственной практики</a:t>
             </a:r>
             <a:endParaRPr lang="en-US" sz="900" dirty="0"/>
           </a:p>
@@ -7066,7 +7303,7 @@
           <a:bodyPr wrap="square" rtlCol="0" anchor="ctr"/>
           <a:lstStyle/>
           <a:p>
-            <a:pPr marL="0" indent="0" algn="ctr">
+            <a:pPr algn="ctr" indent="0" marL="0">
               <a:buNone/>
             </a:pPr>
             <a:r>
@@ -7105,7 +7342,7 @@
           <a:bodyPr wrap="square" rtlCol="0" anchor="ctr"/>
           <a:lstStyle/>
           <a:p>
-            <a:pPr marL="0" indent="0" algn="r">
+            <a:pPr algn="r" indent="0" marL="0">
               <a:buNone/>
             </a:pPr>
             <a:r>
@@ -7171,7 +7408,7 @@
           <a:bodyPr wrap="square" rtlCol="0" anchor="ctr"/>
           <a:lstStyle/>
           <a:p>
-            <a:pPr marL="0" indent="0">
+            <a:pPr indent="0" marL="0">
               <a:buNone/>
             </a:pPr>
             <a:r>
@@ -7210,7 +7447,7 @@
           <a:bodyPr wrap="square" rtlCol="0" anchor="ctr"/>
           <a:lstStyle/>
           <a:p>
-            <a:pPr marL="0" indent="0">
+            <a:pPr indent="0" marL="0">
               <a:buNone/>
             </a:pPr>
             <a:r>
@@ -7225,6 +7462,9 @@
               <a:t>1. Абстрактность астрофизической теории
 </a:t>
             </a:r>
+            <a:pPr indent="0" marL="0">
+              <a:buNone/>
+            </a:pPr>
             <a:r>
               <a:rPr lang="en-US" sz="1050" dirty="0">
                 <a:solidFill>
@@ -7237,6 +7477,9 @@
               <a:t>Искривление пространства-времени, предел Чандрасекара, гравитационное линзирование крайне сложно воспринимаются студентами по статичным плоским формулам в учебниках.
 </a:t>
             </a:r>
+            <a:pPr indent="0" marL="0">
+              <a:buNone/>
+            </a:pPr>
             <a:r>
               <a:rPr lang="en-US" sz="1150" b="1" dirty="0">
                 <a:solidFill>
@@ -7249,6 +7492,9 @@
               <a:t>2. Дефицит интерактивных образовательных сред
 </a:t>
             </a:r>
+            <a:pPr indent="0" marL="0">
+              <a:buNone/>
+            </a:pPr>
             <a:r>
               <a:rPr lang="en-US" sz="1050" dirty="0">
                 <a:solidFill>
@@ -7261,6 +7507,9 @@
               <a:t>Большинство доступных веб-демонстраций сводятся к упрощенной 2D-ньютоновской гравитации без релятивизма, эффекта Доплера и термодинамики звезд.
 </a:t>
             </a:r>
+            <a:pPr indent="0" marL="0">
+              <a:buNone/>
+            </a:pPr>
             <a:r>
               <a:rPr lang="en-US" sz="1150" b="1" dirty="0">
                 <a:solidFill>
@@ -7273,6 +7522,9 @@
               <a:t>3. Сложность установки научных пакетов
 </a:t>
             </a:r>
+            <a:pPr indent="0" marL="0">
+              <a:buNone/>
+            </a:pPr>
             <a:r>
               <a:rPr lang="en-US" sz="1050" dirty="0">
                 <a:solidFill>
@@ -7336,7 +7588,7 @@
           <a:bodyPr wrap="square" rtlCol="0" anchor="ctr"/>
           <a:lstStyle/>
           <a:p>
-            <a:pPr marL="0" indent="0">
+            <a:pPr indent="0" marL="0">
               <a:buNone/>
             </a:pPr>
             <a:r>
@@ -7375,7 +7627,7 @@
           <a:bodyPr wrap="square" rtlCol="0" anchor="ctr"/>
           <a:lstStyle/>
           <a:p>
-            <a:pPr marL="0" indent="0">
+            <a:pPr indent="0" marL="0">
               <a:buNone/>
             </a:pPr>
             <a:r>
@@ -7390,6 +7642,9 @@
               <a:t>1. Запуск в браузере в один клик (Zero Install)
 </a:t>
             </a:r>
+            <a:pPr indent="0" marL="0">
+              <a:buNone/>
+            </a:pPr>
             <a:r>
               <a:rPr lang="en-US" sz="1050" dirty="0">
                 <a:solidFill>
@@ -7402,6 +7657,9 @@
               <a:t>Не требует серверов, компиляторов и установки плагинов. Полная кроссплатформенность: работает на десктопах, ноутбуках и мобильных устройствах.
 </a:t>
             </a:r>
+            <a:pPr indent="0" marL="0">
+              <a:buNone/>
+            </a:pPr>
             <a:r>
               <a:rPr lang="en-US" sz="1150" b="1" dirty="0">
                 <a:solidFill>
@@ -7414,6 +7672,9 @@
               <a:t>2. Научная строгость и реалистичные законы
 </a:t>
             </a:r>
+            <a:pPr indent="0" marL="0">
+              <a:buNone/>
+            </a:pPr>
             <a:r>
               <a:rPr lang="en-US" sz="1050" dirty="0">
                 <a:solidFill>
@@ -7426,6 +7687,9 @@
               <a:t>Симплектический интегратор Верле гарантирует сохранение энергии и импульса. Моделируются реальные пределы Оппенгеймера-Волкова, предел Роша и термоядерный нуклеосинтез.
 </a:t>
             </a:r>
+            <a:pPr indent="0" marL="0">
+              <a:buNone/>
+            </a:pPr>
             <a:r>
               <a:rPr lang="en-US" sz="1150" b="1" dirty="0">
                 <a:solidFill>
@@ -7438,6 +7702,9 @@
               <a:t>3. Высокая производительность (GPU &amp; Canvas)
 </a:t>
             </a:r>
+            <a:pPr indent="0" marL="0">
+              <a:buNone/>
+            </a:pPr>
             <a:r>
               <a:rPr lang="en-US" sz="1050" dirty="0">
                 <a:solidFill>
@@ -7469,7 +7736,6 @@
         <a:solidFill>
           <a:srgbClr val="0B0F19"/>
         </a:solidFill>
-        <a:effectLst/>
       </p:bgPr>
     </p:bg>
     <p:spTree>
@@ -7507,7 +7773,7 @@
           <a:bodyPr wrap="square" rtlCol="0" anchor="ctr"/>
           <a:lstStyle/>
           <a:p>
-            <a:pPr marL="0" indent="0">
+            <a:pPr indent="0" marL="0">
               <a:buNone/>
             </a:pPr>
             <a:r>
@@ -7546,7 +7812,7 @@
           <a:bodyPr wrap="square" rtlCol="0" anchor="ctr"/>
           <a:lstStyle/>
           <a:p>
-            <a:pPr marL="0" indent="0">
+            <a:pPr indent="0" marL="0">
               <a:buNone/>
             </a:pPr>
             <a:r>
@@ -7635,7 +7901,7 @@
           <a:bodyPr wrap="square" rtlCol="0" anchor="ctr"/>
           <a:lstStyle/>
           <a:p>
-            <a:pPr marL="0" indent="0">
+            <a:pPr indent="0" marL="0">
               <a:buNone/>
             </a:pPr>
             <a:r>
@@ -7647,18 +7913,7 @@
                 <a:ea typeface="Segoe UI" pitchFamily="34" charset="-122"/>
                 <a:cs typeface="Segoe UI" pitchFamily="34" charset="-120"/>
               </a:rPr>
-              <a:t>StellarGenesis v1.0 • </a:t>
-            </a:r>
-            <a:r>
-              <a:rPr lang="ru-RU" sz="900" dirty="0">
-                <a:solidFill>
-                  <a:srgbClr val="64748B"/>
-                </a:solidFill>
-                <a:latin typeface="Segoe UI" pitchFamily="34" charset="0"/>
-                <a:ea typeface="Segoe UI" pitchFamily="34" charset="-122"/>
-                <a:cs typeface="Segoe UI" pitchFamily="34" charset="-120"/>
-              </a:rPr>
-              <a:t>Защита проекта учебной практики</a:t>
+              <a:t>StellarGenesis v1.0 • Защита проекта производственной практики</a:t>
             </a:r>
             <a:endParaRPr lang="en-US" sz="900" dirty="0"/>
           </a:p>
@@ -7685,7 +7940,7 @@
           <a:bodyPr wrap="square" rtlCol="0" anchor="ctr"/>
           <a:lstStyle/>
           <a:p>
-            <a:pPr marL="0" indent="0" algn="ctr">
+            <a:pPr algn="ctr" indent="0" marL="0">
               <a:buNone/>
             </a:pPr>
             <a:r>
@@ -7724,7 +7979,7 @@
           <a:bodyPr wrap="square" rtlCol="0" anchor="ctr"/>
           <a:lstStyle/>
           <a:p>
-            <a:pPr marL="0" indent="0" algn="r">
+            <a:pPr algn="r" indent="0" marL="0">
               <a:buNone/>
             </a:pPr>
             <a:r>
@@ -7790,7 +8045,7 @@
           <a:bodyPr wrap="square" rtlCol="0" anchor="ctr"/>
           <a:lstStyle/>
           <a:p>
-            <a:pPr marL="0" indent="0">
+            <a:pPr indent="0" marL="0">
               <a:buNone/>
             </a:pPr>
             <a:r>
@@ -7829,7 +8084,7 @@
           <a:bodyPr wrap="square" rtlCol="0" anchor="ctr"/>
           <a:lstStyle/>
           <a:p>
-            <a:pPr marL="0" indent="0">
+            <a:pPr indent="0" marL="0">
               <a:buNone/>
             </a:pPr>
             <a:r>
@@ -7895,7 +8150,7 @@
           <a:bodyPr wrap="square" rtlCol="0" anchor="ctr"/>
           <a:lstStyle/>
           <a:p>
-            <a:pPr marL="0" indent="0">
+            <a:pPr indent="0" marL="0">
               <a:buNone/>
             </a:pPr>
             <a:r>
@@ -7934,7 +8189,7 @@
           <a:bodyPr wrap="square" rtlCol="0" anchor="ctr"/>
           <a:lstStyle/>
           <a:p>
-            <a:pPr marL="0" indent="0">
+            <a:pPr indent="0" marL="0">
               <a:buNone/>
             </a:pPr>
             <a:r>
@@ -7973,7 +8228,7 @@
           <a:bodyPr wrap="square" rtlCol="0" anchor="ctr"/>
           <a:lstStyle/>
           <a:p>
-            <a:pPr marL="0" indent="0">
+            <a:pPr indent="0" marL="0">
               <a:buNone/>
             </a:pPr>
             <a:r>
@@ -8039,7 +8294,7 @@
           <a:bodyPr wrap="square" rtlCol="0" anchor="ctr"/>
           <a:lstStyle/>
           <a:p>
-            <a:pPr marL="0" indent="0">
+            <a:pPr indent="0" marL="0">
               <a:buNone/>
             </a:pPr>
             <a:r>
@@ -8078,7 +8333,7 @@
           <a:bodyPr wrap="square" rtlCol="0" anchor="ctr"/>
           <a:lstStyle/>
           <a:p>
-            <a:pPr marL="0" indent="0">
+            <a:pPr indent="0" marL="0">
               <a:buNone/>
             </a:pPr>
             <a:r>
@@ -8117,7 +8372,7 @@
           <a:bodyPr wrap="square" rtlCol="0" anchor="ctr"/>
           <a:lstStyle/>
           <a:p>
-            <a:pPr marL="0" indent="0">
+            <a:pPr indent="0" marL="0">
               <a:buNone/>
             </a:pPr>
             <a:r>
@@ -8183,7 +8438,7 @@
           <a:bodyPr wrap="square" rtlCol="0" anchor="ctr"/>
           <a:lstStyle/>
           <a:p>
-            <a:pPr marL="0" indent="0">
+            <a:pPr indent="0" marL="0">
               <a:buNone/>
             </a:pPr>
             <a:r>
@@ -8222,7 +8477,7 @@
           <a:bodyPr wrap="square" rtlCol="0" anchor="ctr"/>
           <a:lstStyle/>
           <a:p>
-            <a:pPr marL="0" indent="0">
+            <a:pPr indent="0" marL="0">
               <a:buNone/>
             </a:pPr>
             <a:r>
@@ -8261,7 +8516,7 @@
           <a:bodyPr wrap="square" rtlCol="0" anchor="ctr"/>
           <a:lstStyle/>
           <a:p>
-            <a:pPr marL="0" indent="0">
+            <a:pPr indent="0" marL="0">
               <a:buNone/>
             </a:pPr>
             <a:r>
@@ -8327,7 +8582,7 @@
           <a:bodyPr wrap="square" rtlCol="0" anchor="ctr"/>
           <a:lstStyle/>
           <a:p>
-            <a:pPr marL="0" indent="0">
+            <a:pPr indent="0" marL="0">
               <a:buNone/>
             </a:pPr>
             <a:r>
@@ -8366,7 +8621,7 @@
           <a:bodyPr wrap="square" rtlCol="0" anchor="ctr"/>
           <a:lstStyle/>
           <a:p>
-            <a:pPr marL="0" indent="0">
+            <a:pPr indent="0" marL="0">
               <a:buNone/>
             </a:pPr>
             <a:r>
@@ -8405,7 +8660,7 @@
           <a:bodyPr wrap="square" rtlCol="0" anchor="ctr"/>
           <a:lstStyle/>
           <a:p>
-            <a:pPr marL="0" indent="0">
+            <a:pPr indent="0" marL="0">
               <a:buNone/>
             </a:pPr>
             <a:r>
@@ -8439,7 +8694,6 @@
         <a:solidFill>
           <a:srgbClr val="0B0F19"/>
         </a:solidFill>
-        <a:effectLst/>
       </p:bgPr>
     </p:bg>
     <p:spTree>
@@ -8477,7 +8731,7 @@
           <a:bodyPr wrap="square" rtlCol="0" anchor="ctr"/>
           <a:lstStyle/>
           <a:p>
-            <a:pPr marL="0" indent="0">
+            <a:pPr indent="0" marL="0">
               <a:buNone/>
             </a:pPr>
             <a:r>
@@ -8516,7 +8770,7 @@
           <a:bodyPr wrap="square" rtlCol="0" anchor="ctr"/>
           <a:lstStyle/>
           <a:p>
-            <a:pPr marL="0" indent="0">
+            <a:pPr indent="0" marL="0">
               <a:buNone/>
             </a:pPr>
             <a:r>
@@ -8605,7 +8859,7 @@
           <a:bodyPr wrap="square" rtlCol="0" anchor="ctr"/>
           <a:lstStyle/>
           <a:p>
-            <a:pPr marL="0" indent="0">
+            <a:pPr indent="0" marL="0">
               <a:buNone/>
             </a:pPr>
             <a:r>
@@ -8617,18 +8871,7 @@
                 <a:ea typeface="Segoe UI" pitchFamily="34" charset="-122"/>
                 <a:cs typeface="Segoe UI" pitchFamily="34" charset="-120"/>
               </a:rPr>
-              <a:t>StellarGenesis v1.0 • </a:t>
-            </a:r>
-            <a:r>
-              <a:rPr lang="ru-RU" sz="900" dirty="0">
-                <a:solidFill>
-                  <a:srgbClr val="64748B"/>
-                </a:solidFill>
-                <a:latin typeface="Segoe UI" pitchFamily="34" charset="0"/>
-                <a:ea typeface="Segoe UI" pitchFamily="34" charset="-122"/>
-                <a:cs typeface="Segoe UI" pitchFamily="34" charset="-120"/>
-              </a:rPr>
-              <a:t>Защита проекта учебной практики</a:t>
+              <a:t>StellarGenesis v1.0 • Защита проекта производственной практики</a:t>
             </a:r>
             <a:endParaRPr lang="en-US" sz="900" dirty="0"/>
           </a:p>
@@ -8655,7 +8898,7 @@
           <a:bodyPr wrap="square" rtlCol="0" anchor="ctr"/>
           <a:lstStyle/>
           <a:p>
-            <a:pPr marL="0" indent="0" algn="ctr">
+            <a:pPr algn="ctr" indent="0" marL="0">
               <a:buNone/>
             </a:pPr>
             <a:r>
@@ -8694,7 +8937,7 @@
           <a:bodyPr wrap="square" rtlCol="0" anchor="ctr"/>
           <a:lstStyle/>
           <a:p>
-            <a:pPr marL="0" indent="0" algn="r">
+            <a:pPr algn="r" indent="0" marL="0">
               <a:buNone/>
             </a:pPr>
             <a:r>
@@ -8760,7 +9003,7 @@
           <a:bodyPr wrap="square" rtlCol="0" anchor="ctr"/>
           <a:lstStyle/>
           <a:p>
-            <a:pPr marL="0" indent="0">
+            <a:pPr indent="0" marL="0">
               <a:buNone/>
             </a:pPr>
             <a:r>
@@ -8799,7 +9042,7 @@
           <a:bodyPr wrap="square" rtlCol="0" anchor="ctr"/>
           <a:lstStyle/>
           <a:p>
-            <a:pPr marL="0" indent="0">
+            <a:pPr indent="0" marL="0">
               <a:buNone/>
             </a:pPr>
             <a:r>
@@ -8858,7 +9101,7 @@
           <a:bodyPr wrap="square" rtlCol="0" anchor="ctr"/>
           <a:lstStyle/>
           <a:p>
-            <a:pPr marL="0" indent="0">
+            <a:pPr indent="0" marL="0">
               <a:buNone/>
             </a:pPr>
             <a:r>
@@ -8873,6 +9116,9 @@
               <a:t>Потребности роли:
 </a:t>
             </a:r>
+            <a:pPr indent="0" marL="0">
+              <a:buNone/>
+            </a:pPr>
             <a:r>
               <a:rPr lang="en-US" sz="1000" dirty="0">
                 <a:solidFill>
@@ -8885,6 +9131,9 @@
               <a:t>Проведение виртуальных лабораторных работ по небесной механике, проверка законов Кеплера, исследование устойчивости орбит.
 </a:t>
             </a:r>
+            <a:pPr indent="0" marL="0">
+              <a:buNone/>
+            </a:pPr>
             <a:r>
               <a:rPr lang="en-US" sz="1100" b="1" dirty="0">
                 <a:solidFill>
@@ -8897,6 +9146,9 @@
               <a:t>Типовой сценарий:
 </a:t>
             </a:r>
+            <a:pPr indent="0" marL="0">
+              <a:buNone/>
+            </a:pPr>
             <a:r>
               <a:rPr lang="en-US" sz="1000" dirty="0">
                 <a:solidFill>
@@ -8909,6 +9161,9 @@
               <a:t>Загружает пресет «Солнечная система», изменяет массу Солнца, замеряет периоды обращения планет и проверяет соотношение T²/a³ = const.
 </a:t>
             </a:r>
+            <a:pPr indent="0" marL="0">
+              <a:buNone/>
+            </a:pPr>
             <a:r>
               <a:rPr lang="en-US" sz="1100" b="1" dirty="0">
                 <a:solidFill>
@@ -8921,6 +9176,9 @@
               <a:t>Практическая ценность:
 </a:t>
             </a:r>
+            <a:pPr indent="0" marL="0">
+              <a:buNone/>
+            </a:pPr>
             <a:r>
               <a:rPr lang="en-US" sz="1000" dirty="0">
                 <a:solidFill>
@@ -8984,7 +9242,7 @@
           <a:bodyPr wrap="square" rtlCol="0" anchor="ctr"/>
           <a:lstStyle/>
           <a:p>
-            <a:pPr marL="0" indent="0">
+            <a:pPr indent="0" marL="0">
               <a:buNone/>
             </a:pPr>
             <a:r>
@@ -9023,7 +9281,7 @@
           <a:bodyPr wrap="square" rtlCol="0" anchor="ctr"/>
           <a:lstStyle/>
           <a:p>
-            <a:pPr marL="0" indent="0">
+            <a:pPr indent="0" marL="0">
               <a:buNone/>
             </a:pPr>
             <a:r>
@@ -9082,7 +9340,7 @@
           <a:bodyPr wrap="square" rtlCol="0" anchor="ctr"/>
           <a:lstStyle/>
           <a:p>
-            <a:pPr marL="0" indent="0">
+            <a:pPr indent="0" marL="0">
               <a:buNone/>
             </a:pPr>
             <a:r>
@@ -9097,6 +9355,9 @@
               <a:t>Потребности роли:
 </a:t>
             </a:r>
+            <a:pPr indent="0" marL="0">
+              <a:buNone/>
+            </a:pPr>
             <a:r>
               <a:rPr lang="en-US" sz="1000" dirty="0">
                 <a:solidFill>
@@ -9109,6 +9370,9 @@
               <a:t>Интерактивное сопровождение лекций по астрономии и физике, вывод на мультимедийный проектор в аудитории.
 </a:t>
             </a:r>
+            <a:pPr indent="0" marL="0">
+              <a:buNone/>
+            </a:pPr>
             <a:r>
               <a:rPr lang="en-US" sz="1100" b="1" dirty="0">
                 <a:solidFill>
@@ -9121,6 +9385,9 @@
               <a:t>Типовой сценарий:
 </a:t>
             </a:r>
+            <a:pPr indent="0" marL="0">
+              <a:buNone/>
+            </a:pPr>
             <a:r>
               <a:rPr lang="en-US" sz="1000" dirty="0">
                 <a:solidFill>
@@ -9133,6 +9400,9 @@
               <a:t>Демонстрирует эффект Доплера на тесной двойной звездной системе, затем ускоряет эволюцию и показывает коллапс ядра в горизонт событий.
 </a:t>
             </a:r>
+            <a:pPr indent="0" marL="0">
+              <a:buNone/>
+            </a:pPr>
             <a:r>
               <a:rPr lang="en-US" sz="1100" b="1" dirty="0">
                 <a:solidFill>
@@ -9145,6 +9415,9 @@
               <a:t>Практическая ценность:
 </a:t>
             </a:r>
+            <a:pPr indent="0" marL="0">
+              <a:buNone/>
+            </a:pPr>
             <a:r>
               <a:rPr lang="en-US" sz="1000" dirty="0">
                 <a:solidFill>
@@ -9208,7 +9481,7 @@
           <a:bodyPr wrap="square" rtlCol="0" anchor="ctr"/>
           <a:lstStyle/>
           <a:p>
-            <a:pPr marL="0" indent="0">
+            <a:pPr indent="0" marL="0">
               <a:buNone/>
             </a:pPr>
             <a:r>
@@ -9247,7 +9520,7 @@
           <a:bodyPr wrap="square" rtlCol="0" anchor="ctr"/>
           <a:lstStyle/>
           <a:p>
-            <a:pPr marL="0" indent="0">
+            <a:pPr indent="0" marL="0">
               <a:buNone/>
             </a:pPr>
             <a:r>
@@ -9306,7 +9579,7 @@
           <a:bodyPr wrap="square" rtlCol="0" anchor="ctr"/>
           <a:lstStyle/>
           <a:p>
-            <a:pPr marL="0" indent="0">
+            <a:pPr indent="0" marL="0">
               <a:buNone/>
             </a:pPr>
             <a:r>
@@ -9321,6 +9594,9 @@
               <a:t>Потребности роли:
 </a:t>
             </a:r>
+            <a:pPr indent="0" marL="0">
+              <a:buNone/>
+            </a:pPr>
             <a:r>
               <a:rPr lang="en-US" sz="1000" dirty="0">
                 <a:solidFill>
@@ -9333,6 +9609,9 @@
               <a:t>Свободное творческое конструирование экзотических гравитационных систем и астрофизических симуляций.
 </a:t>
             </a:r>
+            <a:pPr indent="0" marL="0">
+              <a:buNone/>
+            </a:pPr>
             <a:r>
               <a:rPr lang="en-US" sz="1100" b="1" dirty="0">
                 <a:solidFill>
@@ -9345,6 +9624,9 @@
               <a:t>Типовой сценарий:
 </a:t>
             </a:r>
+            <a:pPr indent="0" marL="0">
+              <a:buNone/>
+            </a:pPr>
             <a:r>
               <a:rPr lang="en-US" sz="1000" dirty="0">
                 <a:solidFill>
@@ -9357,6 +9639,9 @@
               <a:t>Спавнит сверхмассивную черную дыру, направляет на нее звезду и наблюдает процесс приливного разрушения с образованием аккреционного диска.
 </a:t>
             </a:r>
+            <a:pPr indent="0" marL="0">
+              <a:buNone/>
+            </a:pPr>
             <a:r>
               <a:rPr lang="en-US" sz="1100" b="1" dirty="0">
                 <a:solidFill>
@@ -9369,6 +9654,9 @@
               <a:t>Практическая ценность:
 </a:t>
             </a:r>
+            <a:pPr indent="0" marL="0">
+              <a:buNone/>
+            </a:pPr>
             <a:r>
               <a:rPr lang="en-US" sz="1000" dirty="0">
                 <a:solidFill>
@@ -9400,7 +9688,6 @@
         <a:solidFill>
           <a:srgbClr val="0B0F19"/>
         </a:solidFill>
-        <a:effectLst/>
       </p:bgPr>
     </p:bg>
     <p:spTree>
@@ -9438,7 +9725,7 @@
           <a:bodyPr wrap="square" rtlCol="0" anchor="ctr"/>
           <a:lstStyle/>
           <a:p>
-            <a:pPr marL="0" indent="0">
+            <a:pPr indent="0" marL="0">
               <a:buNone/>
             </a:pPr>
             <a:r>
@@ -9477,7 +9764,7 @@
           <a:bodyPr wrap="square" rtlCol="0" anchor="ctr"/>
           <a:lstStyle/>
           <a:p>
-            <a:pPr marL="0" indent="0">
+            <a:pPr indent="0" marL="0">
               <a:buNone/>
             </a:pPr>
             <a:r>
@@ -9566,7 +9853,7 @@
           <a:bodyPr wrap="square" rtlCol="0" anchor="ctr"/>
           <a:lstStyle/>
           <a:p>
-            <a:pPr marL="0" indent="0">
+            <a:pPr indent="0" marL="0">
               <a:buNone/>
             </a:pPr>
             <a:r>
@@ -9578,18 +9865,7 @@
                 <a:ea typeface="Segoe UI" pitchFamily="34" charset="-122"/>
                 <a:cs typeface="Segoe UI" pitchFamily="34" charset="-120"/>
               </a:rPr>
-              <a:t>StellarGenesis v1.0 • </a:t>
-            </a:r>
-            <a:r>
-              <a:rPr lang="ru-RU" sz="900" dirty="0">
-                <a:solidFill>
-                  <a:srgbClr val="64748B"/>
-                </a:solidFill>
-                <a:latin typeface="Segoe UI" pitchFamily="34" charset="0"/>
-                <a:ea typeface="Segoe UI" pitchFamily="34" charset="-122"/>
-                <a:cs typeface="Segoe UI" pitchFamily="34" charset="-120"/>
-              </a:rPr>
-              <a:t>Защита проекта учебной практики</a:t>
+              <a:t>StellarGenesis v1.0 • Защита проекта производственной практики</a:t>
             </a:r>
             <a:endParaRPr lang="en-US" sz="900" dirty="0"/>
           </a:p>
@@ -9616,7 +9892,7 @@
           <a:bodyPr wrap="square" rtlCol="0" anchor="ctr"/>
           <a:lstStyle/>
           <a:p>
-            <a:pPr marL="0" indent="0" algn="ctr">
+            <a:pPr algn="ctr" indent="0" marL="0">
               <a:buNone/>
             </a:pPr>
             <a:r>
@@ -9655,7 +9931,7 @@
           <a:bodyPr wrap="square" rtlCol="0" anchor="ctr"/>
           <a:lstStyle/>
           <a:p>
-            <a:pPr marL="0" indent="0" algn="r">
+            <a:pPr algn="r" indent="0" marL="0">
               <a:buNone/>
             </a:pPr>
             <a:r>
@@ -9721,7 +9997,7 @@
           <a:bodyPr wrap="square" rtlCol="0" anchor="ctr"/>
           <a:lstStyle/>
           <a:p>
-            <a:pPr marL="0" indent="0">
+            <a:pPr indent="0" marL="0">
               <a:buNone/>
             </a:pPr>
             <a:r>
@@ -9760,7 +10036,7 @@
           <a:bodyPr wrap="square" rtlCol="0" anchor="ctr"/>
           <a:lstStyle/>
           <a:p>
-            <a:pPr marL="0" indent="0">
+            <a:pPr indent="0" marL="0">
               <a:buNone/>
             </a:pPr>
             <a:r>
@@ -9826,7 +10102,7 @@
           <a:bodyPr wrap="square" rtlCol="0" anchor="ctr"/>
           <a:lstStyle/>
           <a:p>
-            <a:pPr marL="0" indent="0">
+            <a:pPr indent="0" marL="0">
               <a:buNone/>
             </a:pPr>
             <a:r>
@@ -9865,7 +10141,7 @@
           <a:bodyPr wrap="square" rtlCol="0" anchor="ctr"/>
           <a:lstStyle/>
           <a:p>
-            <a:pPr marL="0" indent="0">
+            <a:pPr indent="0" marL="0">
               <a:buNone/>
             </a:pPr>
             <a:r>
@@ -9931,7 +10207,7 @@
           <a:bodyPr wrap="square" rtlCol="0" anchor="ctr"/>
           <a:lstStyle/>
           <a:p>
-            <a:pPr marL="0" indent="0">
+            <a:pPr indent="0" marL="0">
               <a:buNone/>
             </a:pPr>
             <a:r>
@@ -9970,7 +10246,7 @@
           <a:bodyPr wrap="square" rtlCol="0" anchor="ctr"/>
           <a:lstStyle/>
           <a:p>
-            <a:pPr marL="0" indent="0">
+            <a:pPr indent="0" marL="0">
               <a:buNone/>
             </a:pPr>
             <a:r>
@@ -10036,7 +10312,7 @@
           <a:bodyPr wrap="square" rtlCol="0" anchor="ctr"/>
           <a:lstStyle/>
           <a:p>
-            <a:pPr marL="0" indent="0">
+            <a:pPr indent="0" marL="0">
               <a:buNone/>
             </a:pPr>
             <a:r>
@@ -10075,7 +10351,7 @@
           <a:bodyPr wrap="square" rtlCol="0" anchor="ctr"/>
           <a:lstStyle/>
           <a:p>
-            <a:pPr marL="0" indent="0">
+            <a:pPr indent="0" marL="0">
               <a:buNone/>
             </a:pPr>
             <a:r>
@@ -10141,7 +10417,7 @@
           <a:bodyPr wrap="square" rtlCol="0" anchor="ctr"/>
           <a:lstStyle/>
           <a:p>
-            <a:pPr marL="0" indent="0">
+            <a:pPr indent="0" marL="0">
               <a:buNone/>
             </a:pPr>
             <a:r>
@@ -10180,7 +10456,7 @@
           <a:bodyPr wrap="square" rtlCol="0" anchor="ctr"/>
           <a:lstStyle/>
           <a:p>
-            <a:pPr marL="0" indent="0">
+            <a:pPr indent="0" marL="0">
               <a:buNone/>
             </a:pPr>
             <a:r>
@@ -10246,7 +10522,7 @@
           <a:bodyPr wrap="square" rtlCol="0" anchor="ctr"/>
           <a:lstStyle/>
           <a:p>
-            <a:pPr marL="0" indent="0">
+            <a:pPr indent="0" marL="0">
               <a:buNone/>
             </a:pPr>
             <a:r>
@@ -10285,7 +10561,7 @@
           <a:bodyPr wrap="square" rtlCol="0" anchor="ctr"/>
           <a:lstStyle/>
           <a:p>
-            <a:pPr marL="0" indent="0">
+            <a:pPr indent="0" marL="0">
               <a:buNone/>
             </a:pPr>
             <a:r>
@@ -10319,7 +10595,6 @@
         <a:solidFill>
           <a:srgbClr val="0B0F19"/>
         </a:solidFill>
-        <a:effectLst/>
       </p:bgPr>
     </p:bg>
     <p:spTree>
@@ -10357,7 +10632,7 @@
           <a:bodyPr wrap="square" rtlCol="0" anchor="ctr"/>
           <a:lstStyle/>
           <a:p>
-            <a:pPr marL="0" indent="0">
+            <a:pPr indent="0" marL="0">
               <a:buNone/>
             </a:pPr>
             <a:r>
@@ -10396,7 +10671,7 @@
           <a:bodyPr wrap="square" rtlCol="0" anchor="ctr"/>
           <a:lstStyle/>
           <a:p>
-            <a:pPr marL="0" indent="0">
+            <a:pPr indent="0" marL="0">
               <a:buNone/>
             </a:pPr>
             <a:r>
@@ -10485,7 +10760,7 @@
           <a:bodyPr wrap="square" rtlCol="0" anchor="ctr"/>
           <a:lstStyle/>
           <a:p>
-            <a:pPr marL="0" indent="0">
+            <a:pPr indent="0" marL="0">
               <a:buNone/>
             </a:pPr>
             <a:r>
@@ -10497,18 +10772,7 @@
                 <a:ea typeface="Segoe UI" pitchFamily="34" charset="-122"/>
                 <a:cs typeface="Segoe UI" pitchFamily="34" charset="-120"/>
               </a:rPr>
-              <a:t>StellarGenesis v1.0 • </a:t>
-            </a:r>
-            <a:r>
-              <a:rPr lang="ru-RU" sz="900" dirty="0">
-                <a:solidFill>
-                  <a:srgbClr val="64748B"/>
-                </a:solidFill>
-                <a:latin typeface="Segoe UI" pitchFamily="34" charset="0"/>
-                <a:ea typeface="Segoe UI" pitchFamily="34" charset="-122"/>
-                <a:cs typeface="Segoe UI" pitchFamily="34" charset="-120"/>
-              </a:rPr>
-              <a:t>Защита проекта учебной практики</a:t>
+              <a:t>StellarGenesis v1.0 • Защита проекта производственной практики</a:t>
             </a:r>
             <a:endParaRPr lang="en-US" sz="900" dirty="0"/>
           </a:p>
@@ -10535,7 +10799,7 @@
           <a:bodyPr wrap="square" rtlCol="0" anchor="ctr"/>
           <a:lstStyle/>
           <a:p>
-            <a:pPr marL="0" indent="0" algn="ctr">
+            <a:pPr algn="ctr" indent="0" marL="0">
               <a:buNone/>
             </a:pPr>
             <a:r>
@@ -10574,7 +10838,7 @@
           <a:bodyPr wrap="square" rtlCol="0" anchor="ctr"/>
           <a:lstStyle/>
           <a:p>
-            <a:pPr marL="0" indent="0" algn="r">
+            <a:pPr algn="r" indent="0" marL="0">
               <a:buNone/>
             </a:pPr>
             <a:r>
@@ -10640,7 +10904,7 @@
           <a:bodyPr wrap="square" rtlCol="0" anchor="ctr"/>
           <a:lstStyle/>
           <a:p>
-            <a:pPr marL="0" indent="0">
+            <a:pPr indent="0" marL="0">
               <a:buNone/>
             </a:pPr>
             <a:r>
@@ -10679,7 +10943,7 @@
           <a:bodyPr wrap="square" rtlCol="0" anchor="ctr"/>
           <a:lstStyle/>
           <a:p>
-            <a:pPr marL="0" indent="0">
+            <a:pPr indent="0" marL="0">
               <a:buNone/>
             </a:pPr>
             <a:r>
@@ -10694,6 +10958,9 @@
               <a:t>1. Интерактивное полотно Canvas 2D (60 FPS)
 </a:t>
             </a:r>
+            <a:pPr indent="0" marL="0">
+              <a:buNone/>
+            </a:pPr>
             <a:r>
               <a:rPr lang="en-US" sz="1000" dirty="0">
                 <a:solidFill>
@@ -10706,6 +10973,9 @@
               <a:t>Отрисовка сотен небесных тел с динамическими трейлами орбит и деформируемой сеткой искривления пространства-времени.
 </a:t>
             </a:r>
+            <a:pPr indent="0" marL="0">
+              <a:buNone/>
+            </a:pPr>
             <a:r>
               <a:rPr lang="en-US" sz="1100" b="1" dirty="0">
                 <a:solidFill>
@@ -10718,6 +10988,9 @@
               <a:t>2. Каталог сценариев (TopNavigation)
 </a:t>
             </a:r>
+            <a:pPr indent="0" marL="0">
+              <a:buNone/>
+            </a:pPr>
             <a:r>
               <a:rPr lang="en-US" sz="1000" dirty="0">
                 <a:solidFill>
@@ -10730,6 +11003,9 @@
               <a:t>Мгновенная загрузка пресетов: «Солнечная система», «Тесная двойная звезда», «Пульсар», «Сверхмассивная черная дыра».
 </a:t>
             </a:r>
+            <a:pPr indent="0" marL="0">
+              <a:buNone/>
+            </a:pPr>
             <a:r>
               <a:rPr lang="en-US" sz="1100" b="1" dirty="0">
                 <a:solidFill>
@@ -10742,6 +11018,9 @@
               <a:t>3. Док быстрого доступа (QuickDock)
 </a:t>
             </a:r>
+            <a:pPr indent="0" marL="0">
+              <a:buNone/>
+            </a:pPr>
             <a:r>
               <a:rPr lang="en-US" sz="1000" dirty="0">
                 <a:solidFill>
@@ -10754,6 +11033,9 @@
               <a:t>Управление паузой, слайдер масштаба времени 0.1x–5.0x, тумблеры отображения векторов скорости и трейлов.
 </a:t>
             </a:r>
+            <a:pPr indent="0" marL="0">
+              <a:buNone/>
+            </a:pPr>
             <a:r>
               <a:rPr lang="en-US" sz="1100" b="1" dirty="0">
                 <a:solidFill>
@@ -10766,6 +11048,9 @@
               <a:t>4. Боковой инспектор (StarInspector)
 </a:t>
             </a:r>
+            <a:pPr indent="0" marL="0">
+              <a:buNone/>
+            </a:pPr>
             <a:r>
               <a:rPr lang="en-US" sz="1000" dirty="0">
                 <a:solidFill>
@@ -10829,7 +11114,7 @@
           <a:bodyPr wrap="square" rtlCol="0" anchor="ctr"/>
           <a:lstStyle/>
           <a:p>
-            <a:pPr marL="0" indent="0">
+            <a:pPr indent="0" marL="0">
               <a:buNone/>
             </a:pPr>
             <a:r>
@@ -10849,14 +11134,14 @@
       </p:sp>
       <p:pic>
         <p:nvPicPr>
-          <p:cNvPr id="14" name="Image 0" descr="/app/applet/docs/screenshots/console.png"/>
+          <p:cNvPr id="14" name="Image 0" descr="/app/applet/docs/screenshots/console.png">    </p:cNvPr>
           <p:cNvPicPr>
             <a:picLocks noChangeAspect="1"/>
           </p:cNvPicPr>
           <p:nvPr/>
         </p:nvPicPr>
         <p:blipFill>
-          <a:blip r:embed="rId3"/>
+          <a:blip r:embed="rId1"/>
           <a:stretch>
             <a:fillRect/>
           </a:stretch>
@@ -10919,7 +11204,7 @@
           <a:bodyPr wrap="square" rtlCol="0" anchor="ctr"/>
           <a:lstStyle/>
           <a:p>
-            <a:pPr marL="0" indent="0" algn="ctr">
+            <a:pPr algn="ctr" indent="0" marL="0">
               <a:buNone/>
             </a:pPr>
             <a:r>
@@ -10936,7 +11221,7 @@
             <a:endParaRPr lang="en-US" sz="1000" dirty="0"/>
           </a:p>
           <a:p>
-            <a:pPr marL="0" indent="0" algn="ctr">
+            <a:pPr algn="ctr" indent="0" marL="0">
               <a:buNone/>
             </a:pPr>
             <a:r>
@@ -10970,7 +11255,6 @@
         <a:solidFill>
           <a:srgbClr val="0B0F19"/>
         </a:solidFill>
-        <a:effectLst/>
       </p:bgPr>
     </p:bg>
     <p:spTree>
@@ -11008,7 +11292,7 @@
           <a:bodyPr wrap="square" rtlCol="0" anchor="ctr"/>
           <a:lstStyle/>
           <a:p>
-            <a:pPr marL="0" indent="0">
+            <a:pPr indent="0" marL="0">
               <a:buNone/>
             </a:pPr>
             <a:r>
@@ -11047,7 +11331,7 @@
           <a:bodyPr wrap="square" rtlCol="0" anchor="ctr"/>
           <a:lstStyle/>
           <a:p>
-            <a:pPr marL="0" indent="0">
+            <a:pPr indent="0" marL="0">
               <a:buNone/>
             </a:pPr>
             <a:r>
@@ -11136,7 +11420,7 @@
           <a:bodyPr wrap="square" rtlCol="0" anchor="ctr"/>
           <a:lstStyle/>
           <a:p>
-            <a:pPr marL="0" indent="0">
+            <a:pPr indent="0" marL="0">
               <a:buNone/>
             </a:pPr>
             <a:r>
@@ -11148,18 +11432,7 @@
                 <a:ea typeface="Segoe UI" pitchFamily="34" charset="-122"/>
                 <a:cs typeface="Segoe UI" pitchFamily="34" charset="-120"/>
               </a:rPr>
-              <a:t>StellarGenesis v1.0 • </a:t>
-            </a:r>
-            <a:r>
-              <a:rPr lang="ru-RU" sz="900" dirty="0">
-                <a:solidFill>
-                  <a:srgbClr val="64748B"/>
-                </a:solidFill>
-                <a:latin typeface="Segoe UI" pitchFamily="34" charset="0"/>
-                <a:ea typeface="Segoe UI" pitchFamily="34" charset="-122"/>
-                <a:cs typeface="Segoe UI" pitchFamily="34" charset="-120"/>
-              </a:rPr>
-              <a:t>Защита проекта учебной практики</a:t>
+              <a:t>StellarGenesis v1.0 • Защита проекта производственной практики</a:t>
             </a:r>
             <a:endParaRPr lang="en-US" sz="900" dirty="0"/>
           </a:p>
@@ -11186,7 +11459,7 @@
           <a:bodyPr wrap="square" rtlCol="0" anchor="ctr"/>
           <a:lstStyle/>
           <a:p>
-            <a:pPr marL="0" indent="0" algn="ctr">
+            <a:pPr algn="ctr" indent="0" marL="0">
               <a:buNone/>
             </a:pPr>
             <a:r>
@@ -11225,7 +11498,7 @@
           <a:bodyPr wrap="square" rtlCol="0" anchor="ctr"/>
           <a:lstStyle/>
           <a:p>
-            <a:pPr marL="0" indent="0" algn="r">
+            <a:pPr algn="r" indent="0" marL="0">
               <a:buNone/>
             </a:pPr>
             <a:r>
@@ -11291,7 +11564,7 @@
           <a:bodyPr wrap="square" rtlCol="0" anchor="ctr"/>
           <a:lstStyle/>
           <a:p>
-            <a:pPr marL="0" indent="0">
+            <a:pPr indent="0" marL="0">
               <a:buNone/>
             </a:pPr>
             <a:r>
@@ -11330,7 +11603,7 @@
           <a:bodyPr wrap="square" rtlCol="0" anchor="ctr"/>
           <a:lstStyle/>
           <a:p>
-            <a:pPr marL="0" indent="0">
+            <a:pPr indent="0" marL="0">
               <a:buNone/>
             </a:pPr>
             <a:r>
@@ -11347,7 +11620,7 @@
             <a:endParaRPr lang="en-US" sz="1000" dirty="0"/>
           </a:p>
           <a:p>
-            <a:pPr marL="0" indent="0">
+            <a:pPr indent="0" marL="0">
               <a:buNone/>
             </a:pPr>
             <a:r>
@@ -11364,7 +11637,7 @@
             <a:endParaRPr lang="en-US" sz="1000" dirty="0"/>
           </a:p>
           <a:p>
-            <a:pPr marL="0" indent="0">
+            <a:pPr indent="0" marL="0">
               <a:buNone/>
             </a:pPr>
             <a:r>
@@ -11381,7 +11654,7 @@
             <a:endParaRPr lang="en-US" sz="1000" dirty="0"/>
           </a:p>
           <a:p>
-            <a:pPr marL="0" indent="0">
+            <a:pPr indent="0" marL="0">
               <a:buNone/>
             </a:pPr>
             <a:r>
@@ -11447,7 +11720,7 @@
           <a:bodyPr wrap="square" rtlCol="0" anchor="ctr"/>
           <a:lstStyle/>
           <a:p>
-            <a:pPr marL="0" indent="0">
+            <a:pPr indent="0" marL="0">
               <a:buNone/>
             </a:pPr>
             <a:r>
@@ -11486,7 +11759,7 @@
           <a:bodyPr wrap="square" rtlCol="0" anchor="ctr"/>
           <a:lstStyle/>
           <a:p>
-            <a:pPr marL="0" indent="0">
+            <a:pPr indent="0" marL="0">
               <a:buNone/>
             </a:pPr>
             <a:r>
@@ -11503,7 +11776,7 @@
             <a:endParaRPr lang="en-US" sz="1000" dirty="0"/>
           </a:p>
           <a:p>
-            <a:pPr marL="0" indent="0">
+            <a:pPr indent="0" marL="0">
               <a:buNone/>
             </a:pPr>
             <a:r>
@@ -11520,7 +11793,7 @@
             <a:endParaRPr lang="en-US" sz="1000" dirty="0"/>
           </a:p>
           <a:p>
-            <a:pPr marL="0" indent="0">
+            <a:pPr indent="0" marL="0">
               <a:buNone/>
             </a:pPr>
             <a:r>
@@ -11537,7 +11810,7 @@
             <a:endParaRPr lang="en-US" sz="1000" dirty="0"/>
           </a:p>
           <a:p>
-            <a:pPr marL="0" indent="0">
+            <a:pPr indent="0" marL="0">
               <a:buNone/>
             </a:pPr>
             <a:r>
@@ -11603,7 +11876,7 @@
           <a:bodyPr wrap="square" rtlCol="0" anchor="ctr"/>
           <a:lstStyle/>
           <a:p>
-            <a:pPr marL="0" indent="0">
+            <a:pPr indent="0" marL="0">
               <a:buNone/>
             </a:pPr>
             <a:r>
@@ -11642,7 +11915,7 @@
           <a:bodyPr wrap="square" rtlCol="0" anchor="ctr"/>
           <a:lstStyle/>
           <a:p>
-            <a:pPr marL="0" indent="0">
+            <a:pPr indent="0" marL="0">
               <a:buNone/>
             </a:pPr>
             <a:r>
@@ -11659,7 +11932,7 @@
             <a:endParaRPr lang="en-US" sz="1000" dirty="0"/>
           </a:p>
           <a:p>
-            <a:pPr marL="0" indent="0">
+            <a:pPr indent="0" marL="0">
               <a:buNone/>
             </a:pPr>
             <a:r>
@@ -11676,7 +11949,7 @@
             <a:endParaRPr lang="en-US" sz="1000" dirty="0"/>
           </a:p>
           <a:p>
-            <a:pPr marL="0" indent="0">
+            <a:pPr indent="0" marL="0">
               <a:buNone/>
             </a:pPr>
             <a:r>
@@ -11693,7 +11966,7 @@
             <a:endParaRPr lang="en-US" sz="1000" dirty="0"/>
           </a:p>
           <a:p>
-            <a:pPr marL="0" indent="0">
+            <a:pPr indent="0" marL="0">
               <a:buNone/>
             </a:pPr>
             <a:r>
@@ -11759,7 +12032,7 @@
           <a:bodyPr wrap="square" rtlCol="0" anchor="ctr"/>
           <a:lstStyle/>
           <a:p>
-            <a:pPr marL="0" indent="0">
+            <a:pPr indent="0" marL="0">
               <a:buNone/>
             </a:pPr>
             <a:r>
@@ -11798,7 +12071,7 @@
           <a:bodyPr wrap="square" rtlCol="0" anchor="ctr"/>
           <a:lstStyle/>
           <a:p>
-            <a:pPr marL="0" indent="0">
+            <a:pPr indent="0" marL="0">
               <a:buNone/>
             </a:pPr>
             <a:r>
@@ -11815,7 +12088,7 @@
             <a:endParaRPr lang="en-US" sz="1000" dirty="0"/>
           </a:p>
           <a:p>
-            <a:pPr marL="0" indent="0">
+            <a:pPr indent="0" marL="0">
               <a:buNone/>
             </a:pPr>
             <a:r>
@@ -11832,7 +12105,7 @@
             <a:endParaRPr lang="en-US" sz="1000" dirty="0"/>
           </a:p>
           <a:p>
-            <a:pPr marL="0" indent="0">
+            <a:pPr indent="0" marL="0">
               <a:buNone/>
             </a:pPr>
             <a:r>
@@ -11849,7 +12122,7 @@
             <a:endParaRPr lang="en-US" sz="1000" dirty="0"/>
           </a:p>
           <a:p>
-            <a:pPr marL="0" indent="0">
+            <a:pPr indent="0" marL="0">
               <a:buNone/>
             </a:pPr>
             <a:r>
@@ -11883,7 +12156,6 @@
         <a:solidFill>
           <a:srgbClr val="0B0F19"/>
         </a:solidFill>
-        <a:effectLst/>
       </p:bgPr>
     </p:bg>
     <p:spTree>
@@ -11921,7 +12193,7 @@
           <a:bodyPr wrap="square" rtlCol="0" anchor="ctr"/>
           <a:lstStyle/>
           <a:p>
-            <a:pPr marL="0" indent="0">
+            <a:pPr indent="0" marL="0">
               <a:buNone/>
             </a:pPr>
             <a:r>
@@ -11960,7 +12232,7 @@
           <a:bodyPr wrap="square" rtlCol="0" anchor="ctr"/>
           <a:lstStyle/>
           <a:p>
-            <a:pPr marL="0" indent="0">
+            <a:pPr indent="0" marL="0">
               <a:buNone/>
             </a:pPr>
             <a:r>
@@ -12049,7 +12321,7 @@
           <a:bodyPr wrap="square" rtlCol="0" anchor="ctr"/>
           <a:lstStyle/>
           <a:p>
-            <a:pPr marL="0" indent="0">
+            <a:pPr indent="0" marL="0">
               <a:buNone/>
             </a:pPr>
             <a:r>
@@ -12061,18 +12333,7 @@
                 <a:ea typeface="Segoe UI" pitchFamily="34" charset="-122"/>
                 <a:cs typeface="Segoe UI" pitchFamily="34" charset="-120"/>
               </a:rPr>
-              <a:t>StellarGenesis v1.0 • </a:t>
-            </a:r>
-            <a:r>
-              <a:rPr lang="ru-RU" sz="900" dirty="0">
-                <a:solidFill>
-                  <a:srgbClr val="64748B"/>
-                </a:solidFill>
-                <a:latin typeface="Segoe UI" pitchFamily="34" charset="0"/>
-                <a:ea typeface="Segoe UI" pitchFamily="34" charset="-122"/>
-                <a:cs typeface="Segoe UI" pitchFamily="34" charset="-120"/>
-              </a:rPr>
-              <a:t>Защита проекта учебной практики</a:t>
+              <a:t>StellarGenesis v1.0 • Защита проекта производственной практики</a:t>
             </a:r>
             <a:endParaRPr lang="en-US" sz="900" dirty="0"/>
           </a:p>
@@ -12099,7 +12360,7 @@
           <a:bodyPr wrap="square" rtlCol="0" anchor="ctr"/>
           <a:lstStyle/>
           <a:p>
-            <a:pPr marL="0" indent="0" algn="ctr">
+            <a:pPr algn="ctr" indent="0" marL="0">
               <a:buNone/>
             </a:pPr>
             <a:r>
@@ -12138,7 +12399,7 @@
           <a:bodyPr wrap="square" rtlCol="0" anchor="ctr"/>
           <a:lstStyle/>
           <a:p>
-            <a:pPr marL="0" indent="0" algn="r">
+            <a:pPr algn="r" indent="0" marL="0">
               <a:buNone/>
             </a:pPr>
             <a:r>
@@ -12204,7 +12465,7 @@
           <a:bodyPr wrap="square" rtlCol="0" anchor="ctr"/>
           <a:lstStyle/>
           <a:p>
-            <a:pPr marL="0" indent="0">
+            <a:pPr indent="0" marL="0">
               <a:buNone/>
             </a:pPr>
             <a:r>
@@ -12243,7 +12504,7 @@
           <a:bodyPr wrap="square" rtlCol="0" anchor="ctr"/>
           <a:lstStyle/>
           <a:p>
-            <a:pPr marL="0" indent="0">
+            <a:pPr indent="0" marL="0">
               <a:buNone/>
             </a:pPr>
             <a:r>
@@ -12258,6 +12519,9 @@
               <a:t>Актор: Пользователь (Студент / Исследователь)
 </a:t>
             </a:r>
+            <a:pPr indent="0" marL="0">
+              <a:buNone/>
+            </a:pPr>
             <a:r>
               <a:rPr lang="en-US" sz="1050" b="1" dirty="0">
                 <a:solidFill>
@@ -12270,6 +12534,9 @@
               <a:t>Основные прецеденты клиентского ядра:
 </a:t>
             </a:r>
+            <a:pPr indent="0" marL="0">
+              <a:buNone/>
+            </a:pPr>
             <a:r>
               <a:rPr lang="en-US" sz="1000" dirty="0">
                 <a:solidFill>
@@ -12280,13 +12547,86 @@
                 <a:cs typeface="Segoe UI" pitchFamily="34" charset="-120"/>
               </a:rPr>
               <a:t>• «Запустить N-body симуляцию» (Базовый сценарий)
-• «Выбрать готовый пресет» (Отношение &lt;&lt;include&gt;&gt;)
-• «Создать кастомное тело» (Задание вектора скорости мыши)
-• «Инициировать коллапс звезды» (Отношение &lt;&lt;extend&gt;&gt;)
-• «Открыть 3D инспектор линзирования» (Three.js модальное окно)
-• «Откатить шаг симуляции (Undo)» (Восстановление снимка)
 </a:t>
             </a:r>
+            <a:pPr indent="0" marL="0">
+              <a:buNone/>
+            </a:pPr>
+            <a:r>
+              <a:rPr lang="en-US" sz="1000" dirty="0">
+                <a:solidFill>
+                  <a:srgbClr val="94A3B8"/>
+                </a:solidFill>
+                <a:latin typeface="Segoe UI" pitchFamily="34" charset="0"/>
+                <a:ea typeface="Segoe UI" pitchFamily="34" charset="-122"/>
+                <a:cs typeface="Segoe UI" pitchFamily="34" charset="-120"/>
+              </a:rPr>
+              <a:t>• «Выбрать готовый пресет» (Отношение &lt;&lt;include&gt;&gt;)
+</a:t>
+            </a:r>
+            <a:pPr indent="0" marL="0">
+              <a:buNone/>
+            </a:pPr>
+            <a:r>
+              <a:rPr lang="en-US" sz="1000" dirty="0">
+                <a:solidFill>
+                  <a:srgbClr val="94A3B8"/>
+                </a:solidFill>
+                <a:latin typeface="Segoe UI" pitchFamily="34" charset="0"/>
+                <a:ea typeface="Segoe UI" pitchFamily="34" charset="-122"/>
+                <a:cs typeface="Segoe UI" pitchFamily="34" charset="-120"/>
+              </a:rPr>
+              <a:t>• «Создать кастомное тело» (Задание вектора скорости мыши)
+</a:t>
+            </a:r>
+            <a:pPr indent="0" marL="0">
+              <a:buNone/>
+            </a:pPr>
+            <a:r>
+              <a:rPr lang="en-US" sz="1000" dirty="0">
+                <a:solidFill>
+                  <a:srgbClr val="94A3B8"/>
+                </a:solidFill>
+                <a:latin typeface="Segoe UI" pitchFamily="34" charset="0"/>
+                <a:ea typeface="Segoe UI" pitchFamily="34" charset="-122"/>
+                <a:cs typeface="Segoe UI" pitchFamily="34" charset="-120"/>
+              </a:rPr>
+              <a:t>• «Инициировать коллапс звезды» (Отношение &lt;&lt;extend&gt;&gt;)
+</a:t>
+            </a:r>
+            <a:pPr indent="0" marL="0">
+              <a:buNone/>
+            </a:pPr>
+            <a:r>
+              <a:rPr lang="en-US" sz="1000" dirty="0">
+                <a:solidFill>
+                  <a:srgbClr val="94A3B8"/>
+                </a:solidFill>
+                <a:latin typeface="Segoe UI" pitchFamily="34" charset="0"/>
+                <a:ea typeface="Segoe UI" pitchFamily="34" charset="-122"/>
+                <a:cs typeface="Segoe UI" pitchFamily="34" charset="-120"/>
+              </a:rPr>
+              <a:t>• «Открыть 3D инспектор линзирования» (Three.js модальное окно)
+</a:t>
+            </a:r>
+            <a:pPr indent="0" marL="0">
+              <a:buNone/>
+            </a:pPr>
+            <a:r>
+              <a:rPr lang="en-US" sz="1000" dirty="0">
+                <a:solidFill>
+                  <a:srgbClr val="94A3B8"/>
+                </a:solidFill>
+                <a:latin typeface="Segoe UI" pitchFamily="34" charset="0"/>
+                <a:ea typeface="Segoe UI" pitchFamily="34" charset="-122"/>
+                <a:cs typeface="Segoe UI" pitchFamily="34" charset="-120"/>
+              </a:rPr>
+              <a:t>• «Откатить шаг симуляции (Undo)» (Восстановление снимка)
+</a:t>
+            </a:r>
+            <a:pPr indent="0" marL="0">
+              <a:buNone/>
+            </a:pPr>
             <a:r>
               <a:rPr lang="en-US" sz="1050" b="1" dirty="0">
                 <a:solidFill>
@@ -12299,6 +12639,9 @@
               <a:t>Архитектурный принцип Edge Computing:
 </a:t>
             </a:r>
+            <a:pPr indent="0" marL="0">
+              <a:buNone/>
+            </a:pPr>
             <a:r>
               <a:rPr lang="en-US" sz="1000" dirty="0">
                 <a:solidFill>
@@ -12362,7 +12705,7 @@
           <a:bodyPr wrap="square" rtlCol="0" anchor="ctr"/>
           <a:lstStyle/>
           <a:p>
-            <a:pPr marL="0" indent="0">
+            <a:pPr indent="0" marL="0">
               <a:buNone/>
             </a:pPr>
             <a:r>
@@ -12401,7 +12744,7 @@
           <a:bodyPr wrap="square" rtlCol="0" anchor="ctr"/>
           <a:lstStyle/>
           <a:p>
-            <a:pPr marL="0" indent="0">
+            <a:pPr indent="0" marL="0">
               <a:buNone/>
             </a:pPr>
             <a:r>
@@ -12416,6 +12759,9 @@
               <a:t>Класс CelestialBody (Физический объект):
 </a:t>
             </a:r>
+            <a:pPr indent="0" marL="0">
+              <a:buNone/>
+            </a:pPr>
             <a:r>
               <a:rPr lang="en-US" sz="950" dirty="0">
                 <a:solidFill>
@@ -12432,6 +12778,9 @@
 + tidalStretch: number; dopplerZ: number;
 </a:t>
             </a:r>
+            <a:pPr indent="0" marL="0">
+              <a:buNone/>
+            </a:pPr>
             <a:r>
               <a:rPr lang="en-US" sz="1100" b="1" dirty="0">
                 <a:solidFill>
@@ -12444,6 +12793,9 @@
               <a:t>Функциональный модуль PhysicsEngine:
 </a:t>
             </a:r>
+            <a:pPr indent="0" marL="0">
+              <a:buNone/>
+            </a:pPr>
             <a:r>
               <a:rPr lang="en-US" sz="950" dirty="0">
                 <a:solidFill>
@@ -12460,6 +12812,9 @@
 + computeDopplerFromVx(vx): number
 </a:t>
             </a:r>
+            <a:pPr indent="0" marL="0">
+              <a:buNone/>
+            </a:pPr>
             <a:r>
               <a:rPr lang="en-US" sz="1100" b="1" dirty="0">
                 <a:solidFill>
@@ -12472,6 +12827,9 @@
               <a:t>Иммутабельное управление состоянием HistoryEngine:
 </a:t>
             </a:r>
+            <a:pPr indent="0" marL="0">
+              <a:buNone/>
+            </a:pPr>
             <a:r>
               <a:rPr lang="en-US" sz="950" dirty="0">
                 <a:solidFill>
@@ -12486,7 +12844,7 @@
             <a:endParaRPr lang="en-US" sz="1100" dirty="0"/>
           </a:p>
           <a:p>
-            <a:pPr marL="0" indent="0">
+            <a:pPr indent="0" marL="0">
               <a:buNone/>
             </a:pPr>
             <a:r>
@@ -12520,7 +12878,6 @@
         <a:solidFill>
           <a:srgbClr val="0B0F19"/>
         </a:solidFill>
-        <a:effectLst/>
       </p:bgPr>
     </p:bg>
     <p:spTree>
@@ -12558,7 +12915,7 @@
           <a:bodyPr wrap="square" rtlCol="0" anchor="ctr"/>
           <a:lstStyle/>
           <a:p>
-            <a:pPr marL="0" indent="0">
+            <a:pPr indent="0" marL="0">
               <a:buNone/>
             </a:pPr>
             <a:r>
@@ -12597,7 +12954,7 @@
           <a:bodyPr wrap="square" rtlCol="0" anchor="ctr"/>
           <a:lstStyle/>
           <a:p>
-            <a:pPr marL="0" indent="0">
+            <a:pPr indent="0" marL="0">
               <a:buNone/>
             </a:pPr>
             <a:r>
@@ -12686,7 +13043,7 @@
           <a:bodyPr wrap="square" rtlCol="0" anchor="ctr"/>
           <a:lstStyle/>
           <a:p>
-            <a:pPr marL="0" indent="0">
+            <a:pPr indent="0" marL="0">
               <a:buNone/>
             </a:pPr>
             <a:r>
@@ -12698,18 +13055,7 @@
                 <a:ea typeface="Segoe UI" pitchFamily="34" charset="-122"/>
                 <a:cs typeface="Segoe UI" pitchFamily="34" charset="-120"/>
               </a:rPr>
-              <a:t>StellarGenesis v1.0 • </a:t>
-            </a:r>
-            <a:r>
-              <a:rPr lang="ru-RU" sz="900" dirty="0">
-                <a:solidFill>
-                  <a:srgbClr val="64748B"/>
-                </a:solidFill>
-                <a:latin typeface="Segoe UI" pitchFamily="34" charset="0"/>
-                <a:ea typeface="Segoe UI" pitchFamily="34" charset="-122"/>
-                <a:cs typeface="Segoe UI" pitchFamily="34" charset="-120"/>
-              </a:rPr>
-              <a:t>Защита проекта учебной практики</a:t>
+              <a:t>StellarGenesis v1.0 • Защита проекта производственной практики</a:t>
             </a:r>
             <a:endParaRPr lang="en-US" sz="900" dirty="0"/>
           </a:p>
@@ -12736,7 +13082,7 @@
           <a:bodyPr wrap="square" rtlCol="0" anchor="ctr"/>
           <a:lstStyle/>
           <a:p>
-            <a:pPr marL="0" indent="0" algn="ctr">
+            <a:pPr algn="ctr" indent="0" marL="0">
               <a:buNone/>
             </a:pPr>
             <a:r>
@@ -12775,7 +13121,7 @@
           <a:bodyPr wrap="square" rtlCol="0" anchor="ctr"/>
           <a:lstStyle/>
           <a:p>
-            <a:pPr marL="0" indent="0" algn="r">
+            <a:pPr algn="r" indent="0" marL="0">
               <a:buNone/>
             </a:pPr>
             <a:r>
@@ -12841,7 +13187,7 @@
           <a:bodyPr wrap="square" rtlCol="0" anchor="ctr"/>
           <a:lstStyle/>
           <a:p>
-            <a:pPr marL="0" indent="0">
+            <a:pPr indent="0" marL="0">
               <a:buNone/>
             </a:pPr>
             <a:r>
@@ -12880,7 +13226,7 @@
           <a:bodyPr wrap="square" rtlCol="0" anchor="ctr"/>
           <a:lstStyle/>
           <a:p>
-            <a:pPr marL="0" indent="0">
+            <a:pPr indent="0" marL="0">
               <a:buNone/>
             </a:pPr>
             <a:r>
@@ -12894,6 +13240,9 @@
               </a:rPr>
               <a:t>Тестовый фреймворк: </a:t>
             </a:r>
+            <a:pPr indent="0" marL="0">
+              <a:buNone/>
+            </a:pPr>
             <a:r>
               <a:rPr lang="en-US" sz="1100" b="1" dirty="0">
                 <a:solidFill>
@@ -12906,6 +13255,9 @@
               <a:t>Vitest v5.0.3 (@vitest/coverage-v8)
 </a:t>
             </a:r>
+            <a:pPr indent="0" marL="0">
+              <a:buNone/>
+            </a:pPr>
             <a:r>
               <a:rPr lang="en-US" sz="1100" b="1" dirty="0">
                 <a:solidFill>
@@ -12917,6 +13269,9 @@
               </a:rPr>
               <a:t>Общий итог тестов: </a:t>
             </a:r>
+            <a:pPr indent="0" marL="0">
+              <a:buNone/>
+            </a:pPr>
             <a:r>
               <a:rPr lang="en-US" sz="1100" b="1" dirty="0">
                 <a:solidFill>
@@ -12929,6 +13284,9 @@
               <a:t>38 unit-тестов в 5 сьютах (100% PASS за 1.6 с)
 </a:t>
             </a:r>
+            <a:pPr indent="0" marL="0">
+              <a:buNone/>
+            </a:pPr>
             <a:r>
               <a:rPr lang="en-US" sz="1100" b="1" dirty="0">
                 <a:solidFill>
@@ -12941,6 +13299,9 @@
               <a:t>Инструментальное покрытие функций ядра:
 </a:t>
             </a:r>
+            <a:pPr indent="0" marL="0">
+              <a:buNone/>
+            </a:pPr>
             <a:r>
               <a:rPr lang="en-US" sz="1000" dirty="0">
                 <a:solidFill>
@@ -12956,6 +13317,9 @@
 • engine.ts — 90.5% математических методов ядра;
 </a:t>
             </a:r>
+            <a:pPr indent="0" marL="0">
+              <a:buNone/>
+            </a:pPr>
             <a:r>
               <a:rPr lang="en-US" sz="1050" b="1" dirty="0">
                 <a:solidFill>
@@ -12968,6 +13332,9 @@
               <a:t>Итоговое покрытие ядра: 72.0% (цель ≥ 70% достигнута)
 </a:t>
             </a:r>
+            <a:pPr indent="0" marL="0">
+              <a:buNone/>
+            </a:pPr>
             <a:r>
               <a:rPr lang="en-US" sz="1100" b="1" dirty="0">
                 <a:solidFill>
@@ -12980,6 +13347,9 @@
               <a:t>Инженерная надежность:
 </a:t>
             </a:r>
+            <a:pPr indent="0" marL="0">
+              <a:buNone/>
+            </a:pPr>
             <a:r>
               <a:rPr lang="en-US" sz="1000" dirty="0">
                 <a:solidFill>
@@ -13043,7 +13413,7 @@
           <a:bodyPr wrap="square" rtlCol="0" anchor="ctr"/>
           <a:lstStyle/>
           <a:p>
-            <a:pPr marL="0" indent="0">
+            <a:pPr indent="0" marL="0">
               <a:buNone/>
             </a:pPr>
             <a:r>
@@ -13063,14 +13433,14 @@
       </p:sp>
       <p:pic>
         <p:nvPicPr>
-          <p:cNvPr id="14" name="Image 0" descr="/app/applet/docs/screenshots/coverage.png"/>
+          <p:cNvPr id="14" name="Image 0" descr="/app/applet/docs/screenshots/coverage.png">    </p:cNvPr>
           <p:cNvPicPr>
             <a:picLocks noChangeAspect="1"/>
           </p:cNvPicPr>
           <p:nvPr/>
         </p:nvPicPr>
         <p:blipFill>
-          <a:blip r:embed="rId3"/>
+          <a:blip r:embed="rId1"/>
           <a:stretch>
             <a:fillRect/>
           </a:stretch>
@@ -13133,7 +13503,7 @@
           <a:bodyPr wrap="square" rtlCol="0" anchor="ctr"/>
           <a:lstStyle/>
           <a:p>
-            <a:pPr marL="0" indent="0" algn="ctr">
+            <a:pPr algn="ctr" indent="0" marL="0">
               <a:buNone/>
             </a:pPr>
             <a:r>
@@ -13150,7 +13520,7 @@
             <a:endParaRPr lang="en-US" sz="1000" dirty="0"/>
           </a:p>
           <a:p>
-            <a:pPr marL="0" indent="0" algn="ctr">
+            <a:pPr algn="ctr" indent="0" marL="0">
               <a:buNone/>
             </a:pPr>
             <a:r>
@@ -13469,299 +13839,4 @@
     </a:ext>
   </a:extLst>
 </a:theme>
-</file>
-
-<file path=ppt/theme/theme2.xml><?xml version="1.0" encoding="utf-8"?>
-<a:theme xmlns:a="http://schemas.openxmlformats.org/drawingml/2006/main" name="Тема Office">
-  <a:themeElements>
-    <a:clrScheme name="Стандартная">
-      <a:dk1>
-        <a:sysClr val="windowText" lastClr="000000"/>
-      </a:dk1>
-      <a:lt1>
-        <a:sysClr val="window" lastClr="FFFFFF"/>
-      </a:lt1>
-      <a:dk2>
-        <a:srgbClr val="44546A"/>
-      </a:dk2>
-      <a:lt2>
-        <a:srgbClr val="E7E6E6"/>
-      </a:lt2>
-      <a:accent1>
-        <a:srgbClr val="4472C4"/>
-      </a:accent1>
-      <a:accent2>
-        <a:srgbClr val="ED7D31"/>
-      </a:accent2>
-      <a:accent3>
-        <a:srgbClr val="A5A5A5"/>
-      </a:accent3>
-      <a:accent4>
-        <a:srgbClr val="FFC000"/>
-      </a:accent4>
-      <a:accent5>
-        <a:srgbClr val="5B9BD5"/>
-      </a:accent5>
-      <a:accent6>
-        <a:srgbClr val="70AD47"/>
-      </a:accent6>
-      <a:hlink>
-        <a:srgbClr val="0563C1"/>
-      </a:hlink>
-      <a:folHlink>
-        <a:srgbClr val="954F72"/>
-      </a:folHlink>
-    </a:clrScheme>
-    <a:fontScheme name="Стандартная">
-      <a:majorFont>
-        <a:latin typeface="Calibri Light" panose="020F0302020204030204"/>
-        <a:ea typeface=""/>
-        <a:cs typeface=""/>
-        <a:font script="Jpan" typeface="游ゴシック Light"/>
-        <a:font script="Hang" typeface="맑은 고딕"/>
-        <a:font script="Hans" typeface="等线 Light"/>
-        <a:font script="Hant" typeface="新細明體"/>
-        <a:font script="Arab" typeface="Times New Roman"/>
-        <a:font script="Hebr" typeface="Times New Roman"/>
-        <a:font script="Thai" typeface="Angsana New"/>
-        <a:font script="Ethi" typeface="Nyala"/>
-        <a:font script="Beng" typeface="Vrinda"/>
-        <a:font script="Gujr" typeface="Shruti"/>
-        <a:font script="Khmr" typeface="MoolBoran"/>
-        <a:font script="Knda" typeface="Tunga"/>
-        <a:font script="Guru" typeface="Raavi"/>
-        <a:font script="Cans" typeface="Euphemia"/>
-        <a:font script="Cher" typeface="Plantagenet Cherokee"/>
-        <a:font script="Yiii" typeface="Microsoft Yi Baiti"/>
-        <a:font script="Tibt" typeface="Microsoft Himalaya"/>
-        <a:font script="Thaa" typeface="MV Boli"/>
-        <a:font script="Deva" typeface="Mangal"/>
-        <a:font script="Telu" typeface="Gautami"/>
-        <a:font script="Taml" typeface="Latha"/>
-        <a:font script="Syrc" typeface="Estrangelo Edessa"/>
-        <a:font script="Orya" typeface="Kalinga"/>
-        <a:font script="Mlym" typeface="Kartika"/>
-        <a:font script="Laoo" typeface="DokChampa"/>
-        <a:font script="Sinh" typeface="Iskoola Pota"/>
-        <a:font script="Mong" typeface="Mongolian Baiti"/>
-        <a:font script="Viet" typeface="Times New Roman"/>
-        <a:font script="Uigh" typeface="Microsoft Uighur"/>
-        <a:font script="Geor" typeface="Sylfaen"/>
-        <a:font script="Armn" typeface="Arial"/>
-        <a:font script="Bugi" typeface="Leelawadee UI"/>
-        <a:font script="Bopo" typeface="Microsoft JhengHei"/>
-        <a:font script="Java" typeface="Javanese Text"/>
-        <a:font script="Lisu" typeface="Segoe UI"/>
-        <a:font script="Mymr" typeface="Myanmar Text"/>
-        <a:font script="Nkoo" typeface="Ebrima"/>
-        <a:font script="Olck" typeface="Nirmala UI"/>
-        <a:font script="Osma" typeface="Ebrima"/>
-        <a:font script="Phag" typeface="Phagspa"/>
-        <a:font script="Syrn" typeface="Estrangelo Edessa"/>
-        <a:font script="Syrj" typeface="Estrangelo Edessa"/>
-        <a:font script="Syre" typeface="Estrangelo Edessa"/>
-        <a:font script="Sora" typeface="Nirmala UI"/>
-        <a:font script="Tale" typeface="Microsoft Tai Le"/>
-        <a:font script="Talu" typeface="Microsoft New Tai Lue"/>
-        <a:font script="Tfng" typeface="Ebrima"/>
-      </a:majorFont>
-      <a:minorFont>
-        <a:latin typeface="Calibri" panose="020F0502020204030204"/>
-        <a:ea typeface=""/>
-        <a:cs typeface=""/>
-        <a:font script="Jpan" typeface="游ゴシック"/>
-        <a:font script="Hang" typeface="맑은 고딕"/>
-        <a:font script="Hans" typeface="等线"/>
-        <a:font script="Hant" typeface="新細明體"/>
-        <a:font script="Arab" typeface="Arial"/>
-        <a:font script="Hebr" typeface="Arial"/>
-        <a:font script="Thai" typeface="Cordia New"/>
-        <a:font script="Ethi" typeface="Nyala"/>
-        <a:font script="Beng" typeface="Vrinda"/>
-        <a:font script="Gujr" typeface="Shruti"/>
-        <a:font script="Khmr" typeface="DaunPenh"/>
-        <a:font script="Knda" typeface="Tunga"/>
-        <a:font script="Guru" typeface="Raavi"/>
-        <a:font script="Cans" typeface="Euphemia"/>
-        <a:font script="Cher" typeface="Plantagenet Cherokee"/>
-        <a:font script="Yiii" typeface="Microsoft Yi Baiti"/>
-        <a:font script="Tibt" typeface="Microsoft Himalaya"/>
-        <a:font script="Thaa" typeface="MV Boli"/>
-        <a:font script="Deva" typeface="Mangal"/>
-        <a:font script="Telu" typeface="Gautami"/>
-        <a:font script="Taml" typeface="Latha"/>
-        <a:font script="Syrc" typeface="Estrangelo Edessa"/>
-        <a:font script="Orya" typeface="Kalinga"/>
-        <a:font script="Mlym" typeface="Kartika"/>
-        <a:font script="Laoo" typeface="DokChampa"/>
-        <a:font script="Sinh" typeface="Iskoola Pota"/>
-        <a:font script="Mong" typeface="Mongolian Baiti"/>
-        <a:font script="Viet" typeface="Arial"/>
-        <a:font script="Uigh" typeface="Microsoft Uighur"/>
-        <a:font script="Geor" typeface="Sylfaen"/>
-        <a:font script="Armn" typeface="Arial"/>
-        <a:font script="Bugi" typeface="Leelawadee UI"/>
-        <a:font script="Bopo" typeface="Microsoft JhengHei"/>
-        <a:font script="Java" typeface="Javanese Text"/>
-        <a:font script="Lisu" typeface="Segoe UI"/>
-        <a:font script="Mymr" typeface="Myanmar Text"/>
-        <a:font script="Nkoo" typeface="Ebrima"/>
-        <a:font script="Olck" typeface="Nirmala UI"/>
-        <a:font script="Osma" typeface="Ebrima"/>
-        <a:font script="Phag" typeface="Phagspa"/>
-        <a:font script="Syrn" typeface="Estrangelo Edessa"/>
-        <a:font script="Syrj" typeface="Estrangelo Edessa"/>
-        <a:font script="Syre" typeface="Estrangelo Edessa"/>
-        <a:font script="Sora" typeface="Nirmala UI"/>
-        <a:font script="Tale" typeface="Microsoft Tai Le"/>
-        <a:font script="Talu" typeface="Microsoft New Tai Lue"/>
-        <a:font script="Tfng" typeface="Ebrima"/>
-      </a:minorFont>
-    </a:fontScheme>
-    <a:fmtScheme name="Стандартная">
-      <a:fillStyleLst>
-        <a:solidFill>
-          <a:schemeClr val="phClr"/>
-        </a:solidFill>
-        <a:gradFill rotWithShape="1">
-          <a:gsLst>
-            <a:gs pos="0">
-              <a:schemeClr val="phClr">
-                <a:lumMod val="110000"/>
-                <a:satMod val="105000"/>
-                <a:tint val="67000"/>
-              </a:schemeClr>
-            </a:gs>
-            <a:gs pos="50000">
-              <a:schemeClr val="phClr">
-                <a:lumMod val="105000"/>
-                <a:satMod val="103000"/>
-                <a:tint val="73000"/>
-              </a:schemeClr>
-            </a:gs>
-            <a:gs pos="100000">
-              <a:schemeClr val="phClr">
-                <a:lumMod val="105000"/>
-                <a:satMod val="109000"/>
-                <a:tint val="81000"/>
-              </a:schemeClr>
-            </a:gs>
-          </a:gsLst>
-          <a:lin ang="5400000" scaled="0"/>
-        </a:gradFill>
-        <a:gradFill rotWithShape="1">
-          <a:gsLst>
-            <a:gs pos="0">
-              <a:schemeClr val="phClr">
-                <a:satMod val="103000"/>
-                <a:lumMod val="102000"/>
-                <a:tint val="94000"/>
-              </a:schemeClr>
-            </a:gs>
-            <a:gs pos="50000">
-              <a:schemeClr val="phClr">
-                <a:satMod val="110000"/>
-                <a:lumMod val="100000"/>
-                <a:shade val="100000"/>
-              </a:schemeClr>
-            </a:gs>
-            <a:gs pos="100000">
-              <a:schemeClr val="phClr">
-                <a:lumMod val="99000"/>
-                <a:satMod val="120000"/>
-                <a:shade val="78000"/>
-              </a:schemeClr>
-            </a:gs>
-          </a:gsLst>
-          <a:lin ang="5400000" scaled="0"/>
-        </a:gradFill>
-      </a:fillStyleLst>
-      <a:lnStyleLst>
-        <a:ln w="6350" cap="flat" cmpd="sng" algn="ctr">
-          <a:solidFill>
-            <a:schemeClr val="phClr"/>
-          </a:solidFill>
-          <a:prstDash val="solid"/>
-          <a:miter lim="800000"/>
-        </a:ln>
-        <a:ln w="12700" cap="flat" cmpd="sng" algn="ctr">
-          <a:solidFill>
-            <a:schemeClr val="phClr"/>
-          </a:solidFill>
-          <a:prstDash val="solid"/>
-          <a:miter lim="800000"/>
-        </a:ln>
-        <a:ln w="19050" cap="flat" cmpd="sng" algn="ctr">
-          <a:solidFill>
-            <a:schemeClr val="phClr"/>
-          </a:solidFill>
-          <a:prstDash val="solid"/>
-          <a:miter lim="800000"/>
-        </a:ln>
-      </a:lnStyleLst>
-      <a:effectStyleLst>
-        <a:effectStyle>
-          <a:effectLst/>
-        </a:effectStyle>
-        <a:effectStyle>
-          <a:effectLst/>
-        </a:effectStyle>
-        <a:effectStyle>
-          <a:effectLst>
-            <a:outerShdw blurRad="57150" dist="19050" dir="5400000" algn="ctr" rotWithShape="0">
-              <a:srgbClr val="000000">
-                <a:alpha val="63000"/>
-              </a:srgbClr>
-            </a:outerShdw>
-          </a:effectLst>
-        </a:effectStyle>
-      </a:effectStyleLst>
-      <a:bgFillStyleLst>
-        <a:solidFill>
-          <a:schemeClr val="phClr"/>
-        </a:solidFill>
-        <a:solidFill>
-          <a:schemeClr val="phClr">
-            <a:tint val="95000"/>
-            <a:satMod val="170000"/>
-          </a:schemeClr>
-        </a:solidFill>
-        <a:gradFill rotWithShape="1">
-          <a:gsLst>
-            <a:gs pos="0">
-              <a:schemeClr val="phClr">
-                <a:tint val="93000"/>
-                <a:satMod val="150000"/>
-                <a:shade val="98000"/>
-                <a:lumMod val="102000"/>
-              </a:schemeClr>
-            </a:gs>
-            <a:gs pos="50000">
-              <a:schemeClr val="phClr">
-                <a:tint val="98000"/>
-                <a:satMod val="130000"/>
-                <a:shade val="90000"/>
-                <a:lumMod val="103000"/>
-              </a:schemeClr>
-            </a:gs>
-            <a:gs pos="100000">
-              <a:schemeClr val="phClr">
-                <a:shade val="63000"/>
-                <a:satMod val="120000"/>
-              </a:schemeClr>
-            </a:gs>
-          </a:gsLst>
-          <a:lin ang="5400000" scaled="0"/>
-        </a:gradFill>
-      </a:bgFillStyleLst>
-    </a:fmtScheme>
-  </a:themeElements>
-  <a:objectDefaults/>
-  <a:extraClrSchemeLst/>
-  <a:extLst>
-    <a:ext uri="{05A4C25C-085E-4340-85A3-A5531E510DB2}">
-      <thm15:themeFamily xmlns:thm15="http://schemas.microsoft.com/office/thememl/2012/main" name="Office Theme" id="{62F939B6-93AF-4DB8-9C6B-D6C7DFDC589F}" vid="{4A3C46E8-61CC-4603-A589-7422A47A8E4A}"/>
-    </a:ext>
-  </a:extLst>
-</a:theme>
 </file>
</xml_diff>